<commit_message>
feat: redo leadership presentation with Flink use-case slides (blueprint outline)
</commit_message>
<xml_diff>
--- a/artifacts/github-export/presentations/leadership-blueprint-presentation.pptx
+++ b/artifacts/github-export/presentations/leadership-blueprint-presentation.pptx
@@ -3093,14 +3093,6 @@
 <file path=ppt/slides/slide1.xml><?xml version="1.0" encoding="utf-8"?>
 <p:sld xmlns:a="http://schemas.openxmlformats.org/drawingml/2006/main" xmlns:p="http://schemas.openxmlformats.org/presentationml/2006/main" xmlns:r="http://schemas.openxmlformats.org/officeDocument/2006/relationships">
   <p:cSld>
-    <p:bg>
-      <p:bgPr>
-        <a:solidFill>
-          <a:srgbClr val="FFFFFF"/>
-        </a:solidFill>
-        <a:effectLst/>
-      </p:bgPr>
-    </p:bg>
     <p:spTree>
       <p:nvGrpSpPr>
         <p:cNvPr id="1" name=""/>
@@ -3110,57 +3102,14 @@
       <p:grpSpPr/>
       <p:sp>
         <p:nvSpPr>
-          <p:cNvPr id="2" name="Rectangle 1"/>
-          <p:cNvSpPr/>
+          <p:cNvPr id="2" name="TextBox 1"/>
+          <p:cNvSpPr txBox="1"/>
           <p:nvPr/>
         </p:nvSpPr>
         <p:spPr>
           <a:xfrm>
-            <a:off x="0" y="0"/>
-            <a:ext cx="12188952" cy="3200400"/>
-          </a:xfrm>
-          <a:prstGeom prst="rect">
-            <a:avLst/>
-          </a:prstGeom>
-          <a:solidFill>
-            <a:srgbClr val="0B3698"/>
-          </a:solidFill>
-          <a:ln>
-            <a:noFill/>
-          </a:ln>
-        </p:spPr>
-        <p:style>
-          <a:lnRef idx="1">
-            <a:schemeClr val="accent1"/>
-          </a:lnRef>
-          <a:fillRef idx="3">
-            <a:schemeClr val="accent1"/>
-          </a:fillRef>
-          <a:effectRef idx="2">
-            <a:schemeClr val="accent1"/>
-          </a:effectRef>
-          <a:fontRef idx="minor">
-            <a:schemeClr val="lt1"/>
-          </a:fontRef>
-        </p:style>
-        <p:txBody>
-          <a:bodyPr rtlCol="0" anchor="ctr"/>
-          <a:lstStyle/>
-          <a:p>
-            <a:pPr algn="ctr"/>
-          </a:p>
-        </p:txBody>
-      </p:sp>
-      <p:sp>
-        <p:nvSpPr>
-          <p:cNvPr id="3" name="TextBox 2"/>
-          <p:cNvSpPr txBox="1"/>
-          <p:nvPr/>
-        </p:nvSpPr>
-        <p:spPr>
-          <a:xfrm>
-            <a:off x="731520" y="548640"/>
-            <a:ext cx="10515600" cy="1280160"/>
+            <a:off x="457200" y="365760"/>
+            <a:ext cx="8229600" cy="640080"/>
           </a:xfrm>
           <a:prstGeom prst="rect">
             <a:avLst/>
@@ -3168,44 +3117,30 @@
           <a:noFill/>
         </p:spPr>
         <p:txBody>
-          <a:bodyPr wrap="square">
+          <a:bodyPr wrap="none">
             <a:spAutoFit/>
           </a:bodyPr>
           <a:lstStyle/>
           <a:p>
-            <a:r>
-              <a:rPr sz="4000" b="1">
-                <a:solidFill>
-                  <a:srgbClr val="FFFFFF"/>
-                </a:solidFill>
-                <a:latin typeface="Calibri"/>
-              </a:rPr>
+            <a:pPr>
+              <a:defRPr sz="2800" b="1"/>
+            </a:pPr>
+            <a:r>
               <a:t>Global Transaction Banking Platform</a:t>
             </a:r>
           </a:p>
-          <a:p>
-            <a:r>
-              <a:rPr sz="2600">
-                <a:solidFill>
-                  <a:srgbClr val="FFFFFF"/>
-                </a:solidFill>
-                <a:latin typeface="Calibri"/>
-              </a:rPr>
-              <a:t>End-to-End Architecture Blueprint</a:t>
-            </a:r>
-          </a:p>
-        </p:txBody>
-      </p:sp>
-      <p:sp>
-        <p:nvSpPr>
-          <p:cNvPr id="4" name="TextBox 3"/>
+        </p:txBody>
+      </p:sp>
+      <p:sp>
+        <p:nvSpPr>
+          <p:cNvPr id="3" name="TextBox 2"/>
           <p:cNvSpPr txBox="1"/>
           <p:nvPr/>
         </p:nvSpPr>
         <p:spPr>
           <a:xfrm>
-            <a:off x="731520" y="2194560"/>
-            <a:ext cx="9144000" cy="822960"/>
+            <a:off x="457200" y="1188720"/>
+            <a:ext cx="8229600" cy="5486400"/>
           </a:xfrm>
           <a:prstGeom prst="rect">
             <a:avLst/>
@@ -3218,59 +3153,28 @@
           </a:bodyPr>
           <a:lstStyle/>
           <a:p>
-            <a:r>
-              <a:rPr sz="1800">
-                <a:solidFill>
-                  <a:srgbClr val="D9E7FC"/>
-                </a:solidFill>
-                <a:latin typeface="Calibri"/>
-              </a:rPr>
-              <a:t>Confluence of Graph, Kinetic Layer, Streaming, and Real-Time Intelligence
-For: Nexus Global</a:t>
-            </a:r>
-          </a:p>
-        </p:txBody>
-      </p:sp>
-      <p:sp>
-        <p:nvSpPr>
-          <p:cNvPr id="5" name="Rectangle 4"/>
-          <p:cNvSpPr/>
-          <p:nvPr/>
-        </p:nvSpPr>
-        <p:spPr>
-          <a:xfrm>
-            <a:off x="731520" y="3246120"/>
-            <a:ext cx="10515600" cy="13716"/>
-          </a:xfrm>
-          <a:prstGeom prst="rect">
-            <a:avLst/>
-          </a:prstGeom>
-          <a:solidFill>
-            <a:srgbClr val="1E56A0"/>
-          </a:solidFill>
-          <a:ln>
-            <a:noFill/>
-          </a:ln>
-        </p:spPr>
-        <p:style>
-          <a:lnRef idx="1">
-            <a:schemeClr val="accent1"/>
-          </a:lnRef>
-          <a:fillRef idx="3">
-            <a:schemeClr val="accent1"/>
-          </a:fillRef>
-          <a:effectRef idx="2">
-            <a:schemeClr val="accent1"/>
-          </a:effectRef>
-          <a:fontRef idx="minor">
-            <a:schemeClr val="lt1"/>
-          </a:fontRef>
-        </p:style>
-        <p:txBody>
-          <a:bodyPr rtlCol="0" anchor="ctr"/>
-          <a:lstStyle/>
-          <a:p>
-            <a:pPr algn="ctr"/>
+            <a:pPr>
+              <a:defRPr sz="1800"/>
+            </a:pPr>
+            <a:r>
+              <a:t>End-to-End Architecture Blueprint</a:t>
+            </a:r>
+          </a:p>
+          <a:p>
+            <a:pPr>
+              <a:defRPr sz="1800"/>
+            </a:pPr>
+            <a:r>
+              <a:t>Confluence of Graph, Kinetic Layer, Streaming, and Real-Time Intelligence</a:t>
+            </a:r>
+          </a:p>
+          <a:p>
+            <a:pPr>
+              <a:defRPr sz="1800"/>
+            </a:pPr>
+            <a:r>
+              <a:t>For: Nexus Global</a:t>
+            </a:r>
           </a:p>
         </p:txBody>
       </p:sp>
@@ -3294,95 +3198,14 @@
       <p:grpSpPr/>
       <p:sp>
         <p:nvSpPr>
-          <p:cNvPr id="2" name="Title 1"/>
-          <p:cNvSpPr>
-            <a:spLocks noGrp="1"/>
-          </p:cNvSpPr>
-          <p:nvPr>
-            <p:ph type="title"/>
-          </p:nvPr>
-        </p:nvSpPr>
-        <p:spPr/>
-        <p:txBody>
-          <a:bodyPr/>
-          <a:lstStyle/>
-          <a:p>
-            <a:r>
-              <a:t>Flink Use Case — Reporting (Regulatory + Operational)</a:t>
-            </a:r>
-          </a:p>
-        </p:txBody>
-      </p:sp>
-      <p:sp>
-        <p:nvSpPr>
-          <p:cNvPr id="3" name="Content Placeholder 2"/>
-          <p:cNvSpPr>
-            <a:spLocks noGrp="1"/>
-          </p:cNvSpPr>
-          <p:nvPr>
-            <p:ph idx="1"/>
-          </p:nvPr>
-        </p:nvSpPr>
-        <p:spPr/>
-        <p:txBody>
-          <a:bodyPr/>
-          <a:lstStyle/>
-          <a:p/>
-        </p:txBody>
-      </p:sp>
-      <p:sp>
-        <p:nvSpPr>
-          <p:cNvPr id="4" name="Rectangle 3"/>
-          <p:cNvSpPr/>
+          <p:cNvPr id="2" name="TextBox 1"/>
+          <p:cNvSpPr txBox="1"/>
           <p:nvPr/>
         </p:nvSpPr>
         <p:spPr>
           <a:xfrm>
-            <a:off x="0" y="0"/>
-            <a:ext cx="9144000" cy="548640"/>
-          </a:xfrm>
-          <a:prstGeom prst="rect">
-            <a:avLst/>
-          </a:prstGeom>
-          <a:solidFill>
-            <a:srgbClr val="1F4792"/>
-          </a:solidFill>
-          <a:ln>
-            <a:noFill/>
-          </a:ln>
-        </p:spPr>
-        <p:style>
-          <a:lnRef idx="1">
-            <a:schemeClr val="accent1"/>
-          </a:lnRef>
-          <a:fillRef idx="3">
-            <a:schemeClr val="accent1"/>
-          </a:fillRef>
-          <a:effectRef idx="2">
-            <a:schemeClr val="accent1"/>
-          </a:effectRef>
-          <a:fontRef idx="minor">
-            <a:schemeClr val="lt1"/>
-          </a:fontRef>
-        </p:style>
-        <p:txBody>
-          <a:bodyPr rtlCol="0" anchor="ctr"/>
-          <a:lstStyle/>
-          <a:p>
-            <a:pPr algn="ctr"/>
-          </a:p>
-        </p:txBody>
-      </p:sp>
-      <p:sp>
-        <p:nvSpPr>
-          <p:cNvPr id="5" name="TextBox 4"/>
-          <p:cNvSpPr txBox="1"/>
-          <p:nvPr/>
-        </p:nvSpPr>
-        <p:spPr>
-          <a:xfrm>
-            <a:off x="640080" y="868680"/>
-            <a:ext cx="7863840" cy="4937760"/>
+            <a:off x="457200" y="365760"/>
+            <a:ext cx="8229600" cy="640080"/>
           </a:xfrm>
           <a:prstGeom prst="rect">
             <a:avLst/>
@@ -3390,68 +3213,71 @@
           <a:noFill/>
         </p:spPr>
         <p:txBody>
+          <a:bodyPr wrap="none">
+            <a:spAutoFit/>
+          </a:bodyPr>
+          <a:lstStyle/>
+          <a:p>
+            <a:pPr>
+              <a:defRPr sz="2800" b="1"/>
+            </a:pPr>
+            <a:r>
+              <a:t>Flink Use Case: Statements (Payments + Ledger)</a:t>
+            </a:r>
+          </a:p>
+        </p:txBody>
+      </p:sp>
+      <p:sp>
+        <p:nvSpPr>
+          <p:cNvPr id="3" name="TextBox 2"/>
+          <p:cNvSpPr txBox="1"/>
+          <p:nvPr/>
+        </p:nvSpPr>
+        <p:spPr>
+          <a:xfrm>
+            <a:off x="457200" y="1188720"/>
+            <a:ext cx="8229600" cy="5486400"/>
+          </a:xfrm>
+          <a:prstGeom prst="rect">
+            <a:avLst/>
+          </a:prstGeom>
+          <a:noFill/>
+        </p:spPr>
+        <p:txBody>
           <a:bodyPr wrap="square">
             <a:spAutoFit/>
           </a:bodyPr>
           <a:lstStyle/>
           <a:p>
             <a:pPr>
-              <a:spcAft>
-                <a:spcPts val="400"/>
-              </a:spcAft>
-              <a:defRPr sz="2000">
-                <a:solidFill>
-                  <a:srgbClr val="3A6A9C"/>
-                </a:solidFill>
-              </a:defRPr>
-            </a:pPr>
-            <a:r>
-              <a:t>• Real-time, Flink-driven aggregation of payments, ledger, and trade events.</a:t>
-            </a:r>
-          </a:p>
-          <a:p>
-            <a:pPr>
-              <a:spcAft>
-                <a:spcPts val="400"/>
-              </a:spcAft>
-              <a:defRPr sz="2000">
-                <a:solidFill>
-                  <a:srgbClr val="3A6A9C"/>
-                </a:solidFill>
-              </a:defRPr>
-            </a:pPr>
-            <a:r>
-              <a:t>• Enriched with entity/relationship context from the canonical graph.</a:t>
-            </a:r>
-          </a:p>
-          <a:p>
-            <a:pPr>
-              <a:spcAft>
-                <a:spcPts val="400"/>
-              </a:spcAft>
-              <a:defRPr sz="2000">
-                <a:solidFill>
-                  <a:srgbClr val="3A6A9C"/>
-                </a:solidFill>
-              </a:defRPr>
-            </a:pPr>
-            <a:r>
-              <a:t>• Produces reporting-ready streams into Delta Lake (tb_canonical.reporting).</a:t>
-            </a:r>
-          </a:p>
-          <a:p>
-            <a:pPr>
-              <a:spcAft>
-                <a:spcPts val="400"/>
-              </a:spcAft>
-              <a:defRPr sz="2000">
-                <a:solidFill>
-                  <a:srgbClr val="3A6A9C"/>
-                </a:solidFill>
-              </a:defRPr>
-            </a:pPr>
-            <a:r>
-              <a:t>• Enables BCBS-239-aligned reporting, audits, and regulatory submissions.</a:t>
+              <a:defRPr sz="1800"/>
+            </a:pPr>
+            <a:r>
+              <a:t>Real-time assembly of statement lines per customer/account from payment and ledger events.</a:t>
+            </a:r>
+          </a:p>
+          <a:p>
+            <a:pPr>
+              <a:defRPr sz="1800"/>
+            </a:pPr>
+            <a:r>
+              <a:t>Handles postings, fees, interest, reversals, and adjustments consistently.</a:t>
+            </a:r>
+          </a:p>
+          <a:p>
+            <a:pPr>
+              <a:defRPr sz="1800"/>
+            </a:pPr>
+            <a:r>
+              <a:t>Ensures per-entity ordering and idempotency; integrates with statement services via Delta Lake.</a:t>
+            </a:r>
+          </a:p>
+          <a:p>
+            <a:pPr>
+              <a:defRPr sz="1800"/>
+            </a:pPr>
+            <a:r>
+              <a:t>Supports transparent, regulator-ready statements from immutable event streams.</a:t>
             </a:r>
           </a:p>
         </p:txBody>
@@ -3476,95 +3302,14 @@
       <p:grpSpPr/>
       <p:sp>
         <p:nvSpPr>
-          <p:cNvPr id="2" name="Title 1"/>
-          <p:cNvSpPr>
-            <a:spLocks noGrp="1"/>
-          </p:cNvSpPr>
-          <p:nvPr>
-            <p:ph type="title"/>
-          </p:nvPr>
-        </p:nvSpPr>
-        <p:spPr/>
-        <p:txBody>
-          <a:bodyPr/>
-          <a:lstStyle/>
-          <a:p>
-            <a:r>
-              <a:t>Flink Use Case — Statements (Payments + Ledger)</a:t>
-            </a:r>
-          </a:p>
-        </p:txBody>
-      </p:sp>
-      <p:sp>
-        <p:nvSpPr>
-          <p:cNvPr id="3" name="Content Placeholder 2"/>
-          <p:cNvSpPr>
-            <a:spLocks noGrp="1"/>
-          </p:cNvSpPr>
-          <p:nvPr>
-            <p:ph idx="1"/>
-          </p:nvPr>
-        </p:nvSpPr>
-        <p:spPr/>
-        <p:txBody>
-          <a:bodyPr/>
-          <a:lstStyle/>
-          <a:p/>
-        </p:txBody>
-      </p:sp>
-      <p:sp>
-        <p:nvSpPr>
-          <p:cNvPr id="4" name="Rectangle 3"/>
-          <p:cNvSpPr/>
+          <p:cNvPr id="2" name="TextBox 1"/>
+          <p:cNvSpPr txBox="1"/>
           <p:nvPr/>
         </p:nvSpPr>
         <p:spPr>
           <a:xfrm>
-            <a:off x="0" y="0"/>
-            <a:ext cx="9144000" cy="548640"/>
-          </a:xfrm>
-          <a:prstGeom prst="rect">
-            <a:avLst/>
-          </a:prstGeom>
-          <a:solidFill>
-            <a:srgbClr val="1F4792"/>
-          </a:solidFill>
-          <a:ln>
-            <a:noFill/>
-          </a:ln>
-        </p:spPr>
-        <p:style>
-          <a:lnRef idx="1">
-            <a:schemeClr val="accent1"/>
-          </a:lnRef>
-          <a:fillRef idx="3">
-            <a:schemeClr val="accent1"/>
-          </a:fillRef>
-          <a:effectRef idx="2">
-            <a:schemeClr val="accent1"/>
-          </a:effectRef>
-          <a:fontRef idx="minor">
-            <a:schemeClr val="lt1"/>
-          </a:fontRef>
-        </p:style>
-        <p:txBody>
-          <a:bodyPr rtlCol="0" anchor="ctr"/>
-          <a:lstStyle/>
-          <a:p>
-            <a:pPr algn="ctr"/>
-          </a:p>
-        </p:txBody>
-      </p:sp>
-      <p:sp>
-        <p:nvSpPr>
-          <p:cNvPr id="5" name="TextBox 4"/>
-          <p:cNvSpPr txBox="1"/>
-          <p:nvPr/>
-        </p:nvSpPr>
-        <p:spPr>
-          <a:xfrm>
-            <a:off x="640080" y="868680"/>
-            <a:ext cx="7863840" cy="4937760"/>
+            <a:off x="457200" y="365760"/>
+            <a:ext cx="8229600" cy="640080"/>
           </a:xfrm>
           <a:prstGeom prst="rect">
             <a:avLst/>
@@ -3572,68 +3317,71 @@
           <a:noFill/>
         </p:spPr>
         <p:txBody>
+          <a:bodyPr wrap="none">
+            <a:spAutoFit/>
+          </a:bodyPr>
+          <a:lstStyle/>
+          <a:p>
+            <a:pPr>
+              <a:defRPr sz="2800" b="1"/>
+            </a:pPr>
+            <a:r>
+              <a:t>Flink Use Case: Cash Flow Forecasting (Treasury / TBP)</a:t>
+            </a:r>
+          </a:p>
+        </p:txBody>
+      </p:sp>
+      <p:sp>
+        <p:nvSpPr>
+          <p:cNvPr id="3" name="TextBox 2"/>
+          <p:cNvSpPr txBox="1"/>
+          <p:nvPr/>
+        </p:nvSpPr>
+        <p:spPr>
+          <a:xfrm>
+            <a:off x="457200" y="1188720"/>
+            <a:ext cx="8229600" cy="5486400"/>
+          </a:xfrm>
+          <a:prstGeom prst="rect">
+            <a:avLst/>
+          </a:prstGeom>
+          <a:noFill/>
+        </p:spPr>
+        <p:txBody>
           <a:bodyPr wrap="square">
             <a:spAutoFit/>
           </a:bodyPr>
           <a:lstStyle/>
           <a:p>
             <a:pPr>
-              <a:spcAft>
-                <a:spcPts val="400"/>
-              </a:spcAft>
-              <a:defRPr sz="2000">
-                <a:solidFill>
-                  <a:srgbClr val="3A6A9C"/>
-                </a:solidFill>
-              </a:defRPr>
-            </a:pPr>
-            <a:r>
-              <a:t>• Assembles real-time statement lines per customer/account from payment and ledger events.</a:t>
-            </a:r>
-          </a:p>
-          <a:p>
-            <a:pPr>
-              <a:spcAft>
-                <a:spcPts val="400"/>
-              </a:spcAft>
-              <a:defRPr sz="2000">
-                <a:solidFill>
-                  <a:srgbClr val="3A6A9C"/>
-                </a:solidFill>
-              </a:defRPr>
-            </a:pPr>
-            <a:r>
-              <a:t>• Handles postings, fees, interest, reversals, and adjustments consistently.</a:t>
-            </a:r>
-          </a:p>
-          <a:p>
-            <a:pPr>
-              <a:spcAft>
-                <a:spcPts val="400"/>
-              </a:spcAft>
-              <a:defRPr sz="2000">
-                <a:solidFill>
-                  <a:srgbClr val="3A6A9C"/>
-                </a:solidFill>
-              </a:defRPr>
-            </a:pPr>
-            <a:r>
-              <a:t>• Ensures per-entity ordering and idempotency; integrates with statement services via Delta Lake.</a:t>
-            </a:r>
-          </a:p>
-          <a:p>
-            <a:pPr>
-              <a:spcAft>
-                <a:spcPts val="400"/>
-              </a:spcAft>
-              <a:defRPr sz="2000">
-                <a:solidFill>
-                  <a:srgbClr val="3A6A9C"/>
-                </a:solidFill>
-              </a:defRPr>
-            </a:pPr>
-            <a:r>
-              <a:t>• Supports transparent, regulator-ready statements built from immutable event streams.</a:t>
+              <a:defRPr sz="1800"/>
+            </a:pPr>
+            <a:r>
+              <a:t>Near-real-time projected cash flows from payments, trades, and vendor-hosted events.</a:t>
+            </a:r>
+          </a:p>
+          <a:p>
+            <a:pPr>
+              <a:defRPr sz="1800"/>
+            </a:pPr>
+            <a:r>
+              <a:t>Maintains per-entity, per-product horizons (T+0/T+1/T+7/T+30) in Flink state.</a:t>
+            </a:r>
+          </a:p>
+          <a:p>
+            <a:pPr>
+              <a:defRPr sz="1800"/>
+            </a:pPr>
+            <a:r>
+              <a:t>Feeds forecasts into Delta Lake for analytics and Treasury dashboards.</a:t>
+            </a:r>
+          </a:p>
+          <a:p>
+            <a:pPr>
+              <a:defRPr sz="1800"/>
+            </a:pPr>
+            <a:r>
+              <a:t>Triggers governance alerts when forecasts breach predefined thresholds.</a:t>
             </a:r>
           </a:p>
         </p:txBody>
@@ -3658,95 +3406,14 @@
       <p:grpSpPr/>
       <p:sp>
         <p:nvSpPr>
-          <p:cNvPr id="2" name="Title 1"/>
-          <p:cNvSpPr>
-            <a:spLocks noGrp="1"/>
-          </p:cNvSpPr>
-          <p:nvPr>
-            <p:ph type="title"/>
-          </p:nvPr>
-        </p:nvSpPr>
-        <p:spPr/>
-        <p:txBody>
-          <a:bodyPr/>
-          <a:lstStyle/>
-          <a:p>
-            <a:r>
-              <a:t>Flink Use Case — Cash Flow Forecasting (Treasury / TBP)</a:t>
-            </a:r>
-          </a:p>
-        </p:txBody>
-      </p:sp>
-      <p:sp>
-        <p:nvSpPr>
-          <p:cNvPr id="3" name="Content Placeholder 2"/>
-          <p:cNvSpPr>
-            <a:spLocks noGrp="1"/>
-          </p:cNvSpPr>
-          <p:nvPr>
-            <p:ph idx="1"/>
-          </p:nvPr>
-        </p:nvSpPr>
-        <p:spPr/>
-        <p:txBody>
-          <a:bodyPr/>
-          <a:lstStyle/>
-          <a:p/>
-        </p:txBody>
-      </p:sp>
-      <p:sp>
-        <p:nvSpPr>
-          <p:cNvPr id="4" name="Rectangle 3"/>
-          <p:cNvSpPr/>
+          <p:cNvPr id="2" name="TextBox 1"/>
+          <p:cNvSpPr txBox="1"/>
           <p:nvPr/>
         </p:nvSpPr>
         <p:spPr>
           <a:xfrm>
-            <a:off x="0" y="0"/>
-            <a:ext cx="9144000" cy="548640"/>
-          </a:xfrm>
-          <a:prstGeom prst="rect">
-            <a:avLst/>
-          </a:prstGeom>
-          <a:solidFill>
-            <a:srgbClr val="1F4792"/>
-          </a:solidFill>
-          <a:ln>
-            <a:noFill/>
-          </a:ln>
-        </p:spPr>
-        <p:style>
-          <a:lnRef idx="1">
-            <a:schemeClr val="accent1"/>
-          </a:lnRef>
-          <a:fillRef idx="3">
-            <a:schemeClr val="accent1"/>
-          </a:fillRef>
-          <a:effectRef idx="2">
-            <a:schemeClr val="accent1"/>
-          </a:effectRef>
-          <a:fontRef idx="minor">
-            <a:schemeClr val="lt1"/>
-          </a:fontRef>
-        </p:style>
-        <p:txBody>
-          <a:bodyPr rtlCol="0" anchor="ctr"/>
-          <a:lstStyle/>
-          <a:p>
-            <a:pPr algn="ctr"/>
-          </a:p>
-        </p:txBody>
-      </p:sp>
-      <p:sp>
-        <p:nvSpPr>
-          <p:cNvPr id="5" name="TextBox 4"/>
-          <p:cNvSpPr txBox="1"/>
-          <p:nvPr/>
-        </p:nvSpPr>
-        <p:spPr>
-          <a:xfrm>
-            <a:off x="640080" y="868680"/>
-            <a:ext cx="7863840" cy="4937760"/>
+            <a:off x="457200" y="365760"/>
+            <a:ext cx="8229600" cy="640080"/>
           </a:xfrm>
           <a:prstGeom prst="rect">
             <a:avLst/>
@@ -3754,68 +3421,71 @@
           <a:noFill/>
         </p:spPr>
         <p:txBody>
+          <a:bodyPr wrap="none">
+            <a:spAutoFit/>
+          </a:bodyPr>
+          <a:lstStyle/>
+          <a:p>
+            <a:pPr>
+              <a:defRPr sz="2800" b="1"/>
+            </a:pPr>
+            <a:r>
+              <a:t>Flink Use Case: Liquidity Monitoring (Real-Time)</a:t>
+            </a:r>
+          </a:p>
+        </p:txBody>
+      </p:sp>
+      <p:sp>
+        <p:nvSpPr>
+          <p:cNvPr id="3" name="TextBox 2"/>
+          <p:cNvSpPr txBox="1"/>
+          <p:nvPr/>
+        </p:nvSpPr>
+        <p:spPr>
+          <a:xfrm>
+            <a:off x="457200" y="1188720"/>
+            <a:ext cx="8229600" cy="5486400"/>
+          </a:xfrm>
+          <a:prstGeom prst="rect">
+            <a:avLst/>
+          </a:prstGeom>
+          <a:noFill/>
+        </p:spPr>
+        <p:txBody>
           <a:bodyPr wrap="square">
             <a:spAutoFit/>
           </a:bodyPr>
           <a:lstStyle/>
           <a:p>
             <a:pPr>
-              <a:spcAft>
-                <a:spcPts val="400"/>
-              </a:spcAft>
-              <a:defRPr sz="2000">
-                <a:solidFill>
-                  <a:srgbClr val="3A6A9C"/>
-                </a:solidFill>
-              </a:defRPr>
-            </a:pPr>
-            <a:r>
-              <a:t>• Near-real-time projected cash flows based on payments, trades, and vendor-hosted events.</a:t>
-            </a:r>
-          </a:p>
-          <a:p>
-            <a:pPr>
-              <a:spcAft>
-                <a:spcPts val="400"/>
-              </a:spcAft>
-              <a:defRPr sz="2000">
-                <a:solidFill>
-                  <a:srgbClr val="3A6A9C"/>
-                </a:solidFill>
-              </a:defRPr>
-            </a:pPr>
-            <a:r>
-              <a:t>• Maintains per-entity, per-product horizons (T+0/T+1/T+7/T+30) in Flink state.</a:t>
-            </a:r>
-          </a:p>
-          <a:p>
-            <a:pPr>
-              <a:spcAft>
-                <a:spcPts val="400"/>
-              </a:spcAft>
-              <a:defRPr sz="2000">
-                <a:solidFill>
-                  <a:srgbClr val="3A6A9C"/>
-                </a:solidFill>
-              </a:defRPr>
-            </a:pPr>
-            <a:r>
-              <a:t>• Feeds forecasts into Delta Lake for analytics and Treasury dashboards.</a:t>
-            </a:r>
-          </a:p>
-          <a:p>
-            <a:pPr>
-              <a:spcAft>
-                <a:spcPts val="400"/>
-              </a:spcAft>
-              <a:defRPr sz="2000">
-                <a:solidFill>
-                  <a:srgbClr val="3A6A9C"/>
-                </a:solidFill>
-              </a:defRPr>
-            </a:pPr>
-            <a:r>
-              <a:t>• Triggers governance alerts when forecasts breach predefined thresholds.</a:t>
+              <a:defRPr sz="1800"/>
+            </a:pPr>
+            <a:r>
+              <a:t>Continuous computation of liquidity positions per entity, pool, and currency.</a:t>
+            </a:r>
+          </a:p>
+          <a:p>
+            <a:pPr>
+              <a:defRPr sz="1800"/>
+            </a:pPr>
+            <a:r>
+              <a:t>Detects breaches and concentration anomalies via rolling windows and cross-source joins.</a:t>
+            </a:r>
+          </a:p>
+          <a:p>
+            <a:pPr>
+              <a:defRPr sz="1800"/>
+            </a:pPr>
+            <a:r>
+              <a:t>Emits governance.alert-events to Risk/Treasury and kinetic.action-events for automatic compensations.</a:t>
+            </a:r>
+          </a:p>
+          <a:p>
+            <a:pPr>
+              <a:defRPr sz="1800"/>
+            </a:pPr>
+            <a:r>
+              <a:t>Aligned with existing pool, sweep, and facility ontology and kinetic rules.</a:t>
             </a:r>
           </a:p>
         </p:txBody>
@@ -3840,95 +3510,14 @@
       <p:grpSpPr/>
       <p:sp>
         <p:nvSpPr>
-          <p:cNvPr id="2" name="Title 1"/>
-          <p:cNvSpPr>
-            <a:spLocks noGrp="1"/>
-          </p:cNvSpPr>
-          <p:nvPr>
-            <p:ph type="title"/>
-          </p:nvPr>
-        </p:nvSpPr>
-        <p:spPr/>
-        <p:txBody>
-          <a:bodyPr/>
-          <a:lstStyle/>
-          <a:p>
-            <a:r>
-              <a:t>Flink Use Case — Liquidity Monitoring (Real-Time)</a:t>
-            </a:r>
-          </a:p>
-        </p:txBody>
-      </p:sp>
-      <p:sp>
-        <p:nvSpPr>
-          <p:cNvPr id="3" name="Content Placeholder 2"/>
-          <p:cNvSpPr>
-            <a:spLocks noGrp="1"/>
-          </p:cNvSpPr>
-          <p:nvPr>
-            <p:ph idx="1"/>
-          </p:nvPr>
-        </p:nvSpPr>
-        <p:spPr/>
-        <p:txBody>
-          <a:bodyPr/>
-          <a:lstStyle/>
-          <a:p/>
-        </p:txBody>
-      </p:sp>
-      <p:sp>
-        <p:nvSpPr>
-          <p:cNvPr id="4" name="Rectangle 3"/>
-          <p:cNvSpPr/>
+          <p:cNvPr id="2" name="TextBox 1"/>
+          <p:cNvSpPr txBox="1"/>
           <p:nvPr/>
         </p:nvSpPr>
         <p:spPr>
           <a:xfrm>
-            <a:off x="0" y="0"/>
-            <a:ext cx="9144000" cy="548640"/>
-          </a:xfrm>
-          <a:prstGeom prst="rect">
-            <a:avLst/>
-          </a:prstGeom>
-          <a:solidFill>
-            <a:srgbClr val="1F4792"/>
-          </a:solidFill>
-          <a:ln>
-            <a:noFill/>
-          </a:ln>
-        </p:spPr>
-        <p:style>
-          <a:lnRef idx="1">
-            <a:schemeClr val="accent1"/>
-          </a:lnRef>
-          <a:fillRef idx="3">
-            <a:schemeClr val="accent1"/>
-          </a:fillRef>
-          <a:effectRef idx="2">
-            <a:schemeClr val="accent1"/>
-          </a:effectRef>
-          <a:fontRef idx="minor">
-            <a:schemeClr val="lt1"/>
-          </a:fontRef>
-        </p:style>
-        <p:txBody>
-          <a:bodyPr rtlCol="0" anchor="ctr"/>
-          <a:lstStyle/>
-          <a:p>
-            <a:pPr algn="ctr"/>
-          </a:p>
-        </p:txBody>
-      </p:sp>
-      <p:sp>
-        <p:nvSpPr>
-          <p:cNvPr id="5" name="TextBox 4"/>
-          <p:cNvSpPr txBox="1"/>
-          <p:nvPr/>
-        </p:nvSpPr>
-        <p:spPr>
-          <a:xfrm>
-            <a:off x="640080" y="868680"/>
-            <a:ext cx="7863840" cy="4937760"/>
+            <a:off x="457200" y="365760"/>
+            <a:ext cx="8229600" cy="640080"/>
           </a:xfrm>
           <a:prstGeom prst="rect">
             <a:avLst/>
@@ -3936,68 +3525,71 @@
           <a:noFill/>
         </p:spPr>
         <p:txBody>
+          <a:bodyPr wrap="none">
+            <a:spAutoFit/>
+          </a:bodyPr>
+          <a:lstStyle/>
+          <a:p>
+            <a:pPr>
+              <a:defRPr sz="2800" b="1"/>
+            </a:pPr>
+            <a:r>
+              <a:t>How It All Fits Together (Summary)</a:t>
+            </a:r>
+          </a:p>
+        </p:txBody>
+      </p:sp>
+      <p:sp>
+        <p:nvSpPr>
+          <p:cNvPr id="3" name="TextBox 2"/>
+          <p:cNvSpPr txBox="1"/>
+          <p:nvPr/>
+        </p:nvSpPr>
+        <p:spPr>
+          <a:xfrm>
+            <a:off x="457200" y="1188720"/>
+            <a:ext cx="8229600" cy="5486400"/>
+          </a:xfrm>
+          <a:prstGeom prst="rect">
+            <a:avLst/>
+          </a:prstGeom>
+          <a:noFill/>
+        </p:spPr>
+        <p:txBody>
           <a:bodyPr wrap="square">
             <a:spAutoFit/>
           </a:bodyPr>
           <a:lstStyle/>
           <a:p>
             <a:pPr>
-              <a:spcAft>
-                <a:spcPts val="400"/>
-              </a:spcAft>
-              <a:defRPr sz="2000">
-                <a:solidFill>
-                  <a:srgbClr val="3A6A9C"/>
-                </a:solidFill>
-              </a:defRPr>
-            </a:pPr>
-            <a:r>
-              <a:t>• Continuous computation of liquidity positions per entity, pool, and currency.</a:t>
-            </a:r>
-          </a:p>
-          <a:p>
-            <a:pPr>
-              <a:spcAft>
-                <a:spcPts val="400"/>
-              </a:spcAft>
-              <a:defRPr sz="2000">
-                <a:solidFill>
-                  <a:srgbClr val="3A6A9C"/>
-                </a:solidFill>
-              </a:defRPr>
-            </a:pPr>
-            <a:r>
-              <a:t>• Detects breaches and concentration anomalies using rolling windows and cross-source joins.</a:t>
-            </a:r>
-          </a:p>
-          <a:p>
-            <a:pPr>
-              <a:spcAft>
-                <a:spcPts val="400"/>
-              </a:spcAft>
-              <a:defRPr sz="2000">
-                <a:solidFill>
-                  <a:srgbClr val="3A6A9C"/>
-                </a:solidFill>
-              </a:defRPr>
-            </a:pPr>
-            <a:r>
-              <a:t>• Feeds governance.alert-events to Risk/Treasury and kinetic.action-events for automatic compensations.</a:t>
-            </a:r>
-          </a:p>
-          <a:p>
-            <a:pPr>
-              <a:spcAft>
-                <a:spcPts val="400"/>
-              </a:spcAft>
-              <a:defRPr sz="2000">
-                <a:solidFill>
-                  <a:srgbClr val="3A6A9C"/>
-                </a:solidFill>
-              </a:defRPr>
-            </a:pPr>
-            <a:r>
-              <a:t>• Fully aligned with existing pool/sweep/facility ontology and kinetic rules.</a:t>
+              <a:defRPr sz="1800"/>
+            </a:pPr>
+            <a:r>
+              <a:t>One ontology, one platform: shared canonical graph across all LOBs.</a:t>
+            </a:r>
+          </a:p>
+          <a:p>
+            <a:pPr>
+              <a:defRPr sz="1800"/>
+            </a:pPr>
+            <a:r>
+              <a:t>Actions, not CRUD: declared operations with proof, rules, and governance.</a:t>
+            </a:r>
+          </a:p>
+          <a:p>
+            <a:pPr>
+              <a:defRPr sz="1800"/>
+            </a:pPr>
+            <a:r>
+              <a:t>Streaming + Flink as the nervous system: real-time correlation and decisions.</a:t>
+            </a:r>
+          </a:p>
+          <a:p>
+            <a:pPr>
+              <a:defRPr sz="1800"/>
+            </a:pPr>
+            <a:r>
+              <a:t>Governance and trust baked in: mandates, audit, and reconstructibility by design.</a:t>
             </a:r>
           </a:p>
         </p:txBody>
@@ -4013,14 +3605,6 @@
 <file path=ppt/slides/slide2.xml><?xml version="1.0" encoding="utf-8"?>
 <p:sld xmlns:a="http://schemas.openxmlformats.org/drawingml/2006/main" xmlns:p="http://schemas.openxmlformats.org/presentationml/2006/main" xmlns:r="http://schemas.openxmlformats.org/officeDocument/2006/relationships">
   <p:cSld>
-    <p:bg>
-      <p:bgPr>
-        <a:solidFill>
-          <a:srgbClr val="FFFFFF"/>
-        </a:solidFill>
-        <a:effectLst/>
-      </p:bgPr>
-    </p:bg>
     <p:spTree>
       <p:nvGrpSpPr>
         <p:cNvPr id="1" name=""/>
@@ -4030,110 +3614,14 @@
       <p:grpSpPr/>
       <p:sp>
         <p:nvSpPr>
-          <p:cNvPr id="2" name="Rectangle 1"/>
-          <p:cNvSpPr/>
+          <p:cNvPr id="2" name="TextBox 1"/>
+          <p:cNvSpPr txBox="1"/>
           <p:nvPr/>
         </p:nvSpPr>
         <p:spPr>
           <a:xfrm>
-            <a:off x="0" y="0"/>
-            <a:ext cx="12188952" cy="777240"/>
-          </a:xfrm>
-          <a:prstGeom prst="rect">
-            <a:avLst/>
-          </a:prstGeom>
-          <a:solidFill>
-            <a:srgbClr val="0B3698"/>
-          </a:solidFill>
-          <a:ln>
-            <a:noFill/>
-          </a:ln>
-        </p:spPr>
-        <p:style>
-          <a:lnRef idx="1">
-            <a:schemeClr val="accent1"/>
-          </a:lnRef>
-          <a:fillRef idx="3">
-            <a:schemeClr val="accent1"/>
-          </a:fillRef>
-          <a:effectRef idx="2">
-            <a:schemeClr val="accent1"/>
-          </a:effectRef>
-          <a:fontRef idx="minor">
-            <a:schemeClr val="lt1"/>
-          </a:fontRef>
-        </p:style>
-        <p:txBody>
-          <a:bodyPr rtlCol="0" anchor="ctr" lIns="457200" tIns="109728"/>
-          <a:lstStyle/>
-          <a:p>
-            <a:pPr algn="l">
-              <a:defRPr sz="2600">
-                <a:solidFill>
-                  <a:srgbClr val="FFFFFF"/>
-                </a:solidFill>
-                <a:latin typeface="Calibri"/>
-              </a:defRPr>
-            </a:pPr>
-            <a:r>
-              <a:t>Executive Summary</a:t>
-            </a:r>
-          </a:p>
-        </p:txBody>
-      </p:sp>
-      <p:sp>
-        <p:nvSpPr>
-          <p:cNvPr id="3" name="Rectangle 2"/>
-          <p:cNvSpPr/>
-          <p:nvPr/>
-        </p:nvSpPr>
-        <p:spPr>
-          <a:xfrm>
-            <a:off x="228600" y="1005840"/>
-            <a:ext cx="11731752" cy="5577840"/>
-          </a:xfrm>
-          <a:prstGeom prst="rect">
-            <a:avLst/>
-          </a:prstGeom>
-          <a:noFill/>
-          <a:ln w="12700">
-            <a:solidFill>
-              <a:srgbClr val="C0D0F0"/>
-            </a:solidFill>
-          </a:ln>
-        </p:spPr>
-        <p:style>
-          <a:lnRef idx="1">
-            <a:schemeClr val="accent1"/>
-          </a:lnRef>
-          <a:fillRef idx="3">
-            <a:schemeClr val="accent1"/>
-          </a:fillRef>
-          <a:effectRef idx="2">
-            <a:schemeClr val="accent1"/>
-          </a:effectRef>
-          <a:fontRef idx="minor">
-            <a:schemeClr val="lt1"/>
-          </a:fontRef>
-        </p:style>
-        <p:txBody>
-          <a:bodyPr rtlCol="0" anchor="ctr"/>
-          <a:lstStyle/>
-          <a:p>
-            <a:pPr algn="ctr"/>
-          </a:p>
-        </p:txBody>
-      </p:sp>
-      <p:sp>
-        <p:nvSpPr>
-          <p:cNvPr id="4" name="TextBox 3"/>
-          <p:cNvSpPr txBox="1"/>
-          <p:nvPr/>
-        </p:nvSpPr>
-        <p:spPr>
-          <a:xfrm>
-            <a:off x="548640" y="1097280"/>
-            <a:ext cx="10972800" cy="5029200"/>
+            <a:off x="457200" y="365760"/>
+            <a:ext cx="8229600" cy="640080"/>
           </a:xfrm>
           <a:prstGeom prst="rect">
             <a:avLst/>
@@ -4141,122 +3629,87 @@
           <a:noFill/>
         </p:spPr>
         <p:txBody>
+          <a:bodyPr wrap="none">
+            <a:spAutoFit/>
+          </a:bodyPr>
+          <a:lstStyle/>
+          <a:p>
+            <a:pPr>
+              <a:defRPr sz="2800" b="1"/>
+            </a:pPr>
+            <a:r>
+              <a:t>Executive Summary</a:t>
+            </a:r>
+          </a:p>
+        </p:txBody>
+      </p:sp>
+      <p:sp>
+        <p:nvSpPr>
+          <p:cNvPr id="3" name="TextBox 2"/>
+          <p:cNvSpPr txBox="1"/>
+          <p:nvPr/>
+        </p:nvSpPr>
+        <p:spPr>
+          <a:xfrm>
+            <a:off x="457200" y="1188720"/>
+            <a:ext cx="8229600" cy="5486400"/>
+          </a:xfrm>
+          <a:prstGeom prst="rect">
+            <a:avLst/>
+          </a:prstGeom>
+          <a:noFill/>
+        </p:spPr>
+        <p:txBody>
           <a:bodyPr wrap="square">
             <a:spAutoFit/>
           </a:bodyPr>
           <a:lstStyle/>
           <a:p>
             <a:pPr>
-              <a:spcBef>
-                <a:spcPts val="200"/>
-              </a:spcBef>
-              <a:spcAft>
-                <a:spcPts val="300"/>
-              </a:spcAft>
-            </a:pPr>
-            <a:r>
-              <a:rPr sz="1800">
-                <a:solidFill>
-                  <a:srgbClr val="1A1A1A"/>
-                </a:solidFill>
-                <a:latin typeface="Calibri"/>
-              </a:rPr>
-              <a:t>• Building a canonical, ontology-driven GTB platform for Nexus Global: one model across CB/CM/WM.</a:t>
-            </a:r>
-          </a:p>
-          <a:p>
-            <a:pPr>
-              <a:spcBef>
-                <a:spcPts val="200"/>
-              </a:spcBef>
-              <a:spcAft>
-                <a:spcPts val="300"/>
-              </a:spcAft>
-            </a:pPr>
-            <a:r>
-              <a:rPr sz="1800">
-                <a:solidFill>
-                  <a:srgbClr val="1A1A1A"/>
-                </a:solidFill>
-                <a:latin typeface="Calibri"/>
-              </a:rPr>
-              <a:t>• Purpose: control, consistency, cross-LOB visibility, speed, regulatory readiness.</a:t>
-            </a:r>
-          </a:p>
-          <a:p>
-            <a:pPr>
-              <a:spcBef>
-                <a:spcPts val="200"/>
-              </a:spcBef>
-              <a:spcAft>
-                <a:spcPts val="300"/>
-              </a:spcAft>
-            </a:pPr>
-            <a:r>
-              <a:rPr sz="1800">
-                <a:solidFill>
-                  <a:srgbClr val="1A1A1A"/>
-                </a:solidFill>
-                <a:latin typeface="Calibri"/>
-              </a:rPr>
-              <a:t>• Pillar 1: Canonical graph (Neo4j) as the single source of truth for entities, relationships, and obligations.</a:t>
-            </a:r>
-          </a:p>
-          <a:p>
-            <a:pPr>
-              <a:spcBef>
-                <a:spcPts val="200"/>
-              </a:spcBef>
-              <a:spcAft>
-                <a:spcPts val="300"/>
-              </a:spcAft>
-            </a:pPr>
-            <a:r>
-              <a:rPr sz="1800">
-                <a:solidFill>
-                  <a:srgbClr val="1A1A1A"/>
-                </a:solidFill>
-                <a:latin typeface="Calibri"/>
-              </a:rPr>
-              <a:t>• Pillar 2: Kinetic layer (PostgreSQL) — declared actions, rules, functions, and an immutable proof registry.</a:t>
-            </a:r>
-          </a:p>
-          <a:p>
-            <a:pPr>
-              <a:spcBef>
-                <a:spcPts val="200"/>
-              </a:spcBef>
-              <a:spcAft>
-                <a:spcPts val="300"/>
-              </a:spcAft>
-            </a:pPr>
-            <a:r>
-              <a:rPr sz="1800">
-                <a:solidFill>
-                  <a:srgbClr val="1A1A1A"/>
-                </a:solidFill>
-                <a:latin typeface="Calibri"/>
-              </a:rPr>
-              <a:t>• Pillar 3: Streaming backbone (Confluent) + Flink on K8s for real-time correlation, reporting, and decisions.</a:t>
-            </a:r>
-          </a:p>
-          <a:p>
-            <a:pPr>
-              <a:spcBef>
-                <a:spcPts val="200"/>
-              </a:spcBef>
-              <a:spcAft>
-                <a:spcPts val="300"/>
-              </a:spcAft>
-            </a:pPr>
-            <a:r>
-              <a:rPr sz="1800">
-                <a:solidFill>
-                  <a:srgbClr val="1A1A1A"/>
-                </a:solidFill>
-                <a:latin typeface="Calibri"/>
-              </a:rPr>
-              <a:t>• Pillar 4: Analytics and history in Delta Lake (Databricks); hot cache in Redis; all fully governed.</a:t>
+              <a:defRPr sz="1800"/>
+            </a:pPr>
+            <a:r>
+              <a:t>Building a canonical, ontology-driven GTB platform for Nexus Global: one model across CB/CM/WM.</a:t>
+            </a:r>
+          </a:p>
+          <a:p>
+            <a:pPr>
+              <a:defRPr sz="1800"/>
+            </a:pPr>
+            <a:r>
+              <a:t>Goals: control, consistency, cross-LOB visibility, speed, regulatory readiness.</a:t>
+            </a:r>
+          </a:p>
+          <a:p>
+            <a:pPr>
+              <a:defRPr sz="1800"/>
+            </a:pPr>
+            <a:r>
+              <a:t>Pillar 1: Canonical graph (Neo4j) as single source of truth for entities, relationships, obligations.</a:t>
+            </a:r>
+          </a:p>
+          <a:p>
+            <a:pPr>
+              <a:defRPr sz="1800"/>
+            </a:pPr>
+            <a:r>
+              <a:t>Pillar 2: Kinetic layer (PostgreSQL) for declared actions, rules, functions, and immutable proof.</a:t>
+            </a:r>
+          </a:p>
+          <a:p>
+            <a:pPr>
+              <a:defRPr sz="1800"/>
+            </a:pPr>
+            <a:r>
+              <a:t>Pillar 3: Streaming backbone (Confluent Cloud) + Flink on K8s for real-time correlation and decisions.</a:t>
+            </a:r>
+          </a:p>
+          <a:p>
+            <a:pPr>
+              <a:defRPr sz="1800"/>
+            </a:pPr>
+            <a:r>
+              <a:t>Pillar 4: Analytics and history in Delta Lake (Databricks); hot cache in Redis; fully governed.</a:t>
             </a:r>
           </a:p>
         </p:txBody>
@@ -4272,14 +3725,6 @@
 <file path=ppt/slides/slide3.xml><?xml version="1.0" encoding="utf-8"?>
 <p:sld xmlns:a="http://schemas.openxmlformats.org/drawingml/2006/main" xmlns:p="http://schemas.openxmlformats.org/presentationml/2006/main" xmlns:r="http://schemas.openxmlformats.org/officeDocument/2006/relationships">
   <p:cSld>
-    <p:bg>
-      <p:bgPr>
-        <a:solidFill>
-          <a:srgbClr val="FFFFFF"/>
-        </a:solidFill>
-        <a:effectLst/>
-      </p:bgPr>
-    </p:bg>
     <p:spTree>
       <p:nvGrpSpPr>
         <p:cNvPr id="1" name=""/>
@@ -4289,67 +3734,14 @@
       <p:grpSpPr/>
       <p:sp>
         <p:nvSpPr>
-          <p:cNvPr id="2" name="Rectangle 1"/>
-          <p:cNvSpPr/>
+          <p:cNvPr id="2" name="TextBox 1"/>
+          <p:cNvSpPr txBox="1"/>
           <p:nvPr/>
         </p:nvSpPr>
         <p:spPr>
           <a:xfrm>
-            <a:off x="0" y="0"/>
-            <a:ext cx="12188952" cy="777240"/>
-          </a:xfrm>
-          <a:prstGeom prst="rect">
-            <a:avLst/>
-          </a:prstGeom>
-          <a:solidFill>
-            <a:srgbClr val="0B3698"/>
-          </a:solidFill>
-          <a:ln>
-            <a:noFill/>
-          </a:ln>
-        </p:spPr>
-        <p:style>
-          <a:lnRef idx="1">
-            <a:schemeClr val="accent1"/>
-          </a:lnRef>
-          <a:fillRef idx="3">
-            <a:schemeClr val="accent1"/>
-          </a:fillRef>
-          <a:effectRef idx="2">
-            <a:schemeClr val="accent1"/>
-          </a:effectRef>
-          <a:fontRef idx="minor">
-            <a:schemeClr val="lt1"/>
-          </a:fontRef>
-        </p:style>
-        <p:txBody>
-          <a:bodyPr rtlCol="0" anchor="ctr" lIns="457200" tIns="109728"/>
-          <a:lstStyle/>
-          <a:p>
-            <a:pPr algn="l">
-              <a:defRPr sz="2600">
-                <a:solidFill>
-                  <a:srgbClr val="FFFFFF"/>
-                </a:solidFill>
-                <a:latin typeface="Calibri"/>
-              </a:defRPr>
-            </a:pPr>
-            <a:r>
-              <a:t>Dimension 1 — Logical Model</a:t>
-            </a:r>
-          </a:p>
-        </p:txBody>
-      </p:sp>
-      <p:sp>
-        <p:nvSpPr>
-          <p:cNvPr id="3" name="TextBox 2"/>
-          <p:cNvSpPr txBox="1"/>
-          <p:nvPr/>
-        </p:nvSpPr>
-        <p:spPr>
-          <a:xfrm>
-            <a:off x="457200" y="347472"/>
-            <a:ext cx="9144000" cy="274320"/>
+            <a:off x="457200" y="365760"/>
+            <a:ext cx="8229600" cy="640080"/>
           </a:xfrm>
           <a:prstGeom prst="rect">
             <a:avLst/>
@@ -4362,73 +3754,25 @@
           </a:bodyPr>
           <a:lstStyle/>
           <a:p>
-            <a:pPr algn="l">
-              <a:defRPr sz="1300">
-                <a:solidFill>
-                  <a:srgbClr val="D9E7FC"/>
-                </a:solidFill>
-                <a:latin typeface="Calibri"/>
-              </a:defRPr>
-            </a:pPr>
-            <a:r>
-              <a:t>Canonical graph as the source of truth</a:t>
-            </a:r>
-          </a:p>
-        </p:txBody>
-      </p:sp>
-      <p:sp>
-        <p:nvSpPr>
-          <p:cNvPr id="4" name="Rectangle 3"/>
-          <p:cNvSpPr/>
+            <a:pPr>
+              <a:defRPr sz="2800" b="1"/>
+            </a:pPr>
+            <a:r>
+              <a:t>Dimension 1 — Logical Model</a:t>
+            </a:r>
+          </a:p>
+        </p:txBody>
+      </p:sp>
+      <p:sp>
+        <p:nvSpPr>
+          <p:cNvPr id="3" name="TextBox 2"/>
+          <p:cNvSpPr txBox="1"/>
           <p:nvPr/>
         </p:nvSpPr>
         <p:spPr>
           <a:xfrm>
-            <a:off x="228600" y="1005840"/>
-            <a:ext cx="11731752" cy="5577840"/>
-          </a:xfrm>
-          <a:prstGeom prst="rect">
-            <a:avLst/>
-          </a:prstGeom>
-          <a:noFill/>
-          <a:ln w="12700">
-            <a:solidFill>
-              <a:srgbClr val="C0D0F0"/>
-            </a:solidFill>
-          </a:ln>
-        </p:spPr>
-        <p:style>
-          <a:lnRef idx="1">
-            <a:schemeClr val="accent1"/>
-          </a:lnRef>
-          <a:fillRef idx="3">
-            <a:schemeClr val="accent1"/>
-          </a:fillRef>
-          <a:effectRef idx="2">
-            <a:schemeClr val="accent1"/>
-          </a:effectRef>
-          <a:fontRef idx="minor">
-            <a:schemeClr val="lt1"/>
-          </a:fontRef>
-        </p:style>
-        <p:txBody>
-          <a:bodyPr rtlCol="0" anchor="ctr"/>
-          <a:lstStyle/>
-          <a:p>
-            <a:pPr algn="ctr"/>
-          </a:p>
-        </p:txBody>
-      </p:sp>
-      <p:sp>
-        <p:nvSpPr>
-          <p:cNvPr id="5" name="TextBox 4"/>
-          <p:cNvSpPr txBox="1"/>
-          <p:nvPr/>
-        </p:nvSpPr>
-        <p:spPr>
-          <a:xfrm>
-            <a:off x="548640" y="1097280"/>
-            <a:ext cx="10972800" cy="5029200"/>
+            <a:off x="457200" y="1188720"/>
+            <a:ext cx="8229600" cy="5486400"/>
           </a:xfrm>
           <a:prstGeom prst="rect">
             <a:avLst/>
@@ -4442,97 +3786,42 @@
           <a:lstStyle/>
           <a:p>
             <a:pPr>
-              <a:spcBef>
-                <a:spcPts val="200"/>
-              </a:spcBef>
-              <a:spcAft>
-                <a:spcPts val="300"/>
-              </a:spcAft>
-            </a:pPr>
-            <a:r>
-              <a:rPr sz="1700">
-                <a:solidFill>
-                  <a:srgbClr val="1A1A1A"/>
-                </a:solidFill>
-                <a:latin typeface="Calibri"/>
-              </a:rPr>
-              <a:t>• Unified canonical graph for all GTB entities: parties, products, accounts, transactions, channels, obligations, mandates, vendors.</a:t>
-            </a:r>
-          </a:p>
-          <a:p>
-            <a:pPr>
-              <a:spcBef>
-                <a:spcPts val="200"/>
-              </a:spcBef>
-              <a:spcAft>
-                <a:spcPts val="300"/>
-              </a:spcAft>
-            </a:pPr>
-            <a:r>
-              <a:rPr sz="1700">
-                <a:solidFill>
-                  <a:srgbClr val="1A1A1A"/>
-                </a:solidFill>
-                <a:latin typeface="Calibri"/>
-              </a:rPr>
-              <a:t>• Every relationship is governed: proposed → verified → active, with an immutable proof chain.</a:t>
-            </a:r>
-          </a:p>
-          <a:p>
-            <a:pPr>
-              <a:spcBef>
-                <a:spcPts val="200"/>
-              </a:spcBef>
-              <a:spcAft>
-                <a:spcPts val="300"/>
-              </a:spcAft>
-            </a:pPr>
-            <a:r>
-              <a:rPr sz="1700">
-                <a:solidFill>
-                  <a:srgbClr val="1A1A1A"/>
-                </a:solidFill>
-                <a:latin typeface="Calibri"/>
-              </a:rPr>
-              <a:t>• Key construct: interfaces (e.g., IIsSettlementTarget, IHasBalance) enable polymorphic, cross-type operations.</a:t>
-            </a:r>
-          </a:p>
-          <a:p>
-            <a:pPr>
-              <a:spcBef>
-                <a:spcPts val="200"/>
-              </a:spcBef>
-              <a:spcAft>
-                <a:spcPts val="300"/>
-              </a:spcAft>
-            </a:pPr>
-            <a:r>
-              <a:rPr sz="1700">
-                <a:solidFill>
-                  <a:srgbClr val="1A1A1A"/>
-                </a:solidFill>
-                <a:latin typeface="Calibri"/>
-              </a:rPr>
-              <a:t>• Vendor-hosted systems (Trade Finance, SCF) live in a Containment Zone; progressive mapping to canonical terms.</a:t>
-            </a:r>
-          </a:p>
-          <a:p>
-            <a:pPr>
-              <a:spcBef>
-                <a:spcPts val="200"/>
-              </a:spcBef>
-              <a:spcAft>
-                <a:spcPts val="300"/>
-              </a:spcAft>
-            </a:pPr>
-            <a:r>
-              <a:rPr sz="1700">
-                <a:solidFill>
-                  <a:srgbClr val="1A1A1A"/>
-                </a:solidFill>
-                <a:latin typeface="Calibri"/>
-              </a:rPr>
-              <a:t>• Graph is the single reference model across CB, CM, WM — no siloed definitions.</a:t>
+              <a:defRPr sz="1800"/>
+            </a:pPr>
+            <a:r>
+              <a:t>Canonical graph is the single source of truth for all GTB entities and relationships.</a:t>
+            </a:r>
+          </a:p>
+          <a:p>
+            <a:pPr>
+              <a:defRPr sz="1800"/>
+            </a:pPr>
+            <a:r>
+              <a:t>Unified ontology across CB, CM, WM: no siloed definitions.</a:t>
+            </a:r>
+          </a:p>
+          <a:p>
+            <a:pPr>
+              <a:defRPr sz="1800"/>
+            </a:pPr>
+            <a:r>
+              <a:t>Core nodes: parties, products, accounts, transactions, channels, obligations, mandates, vendors.</a:t>
+            </a:r>
+          </a:p>
+          <a:p>
+            <a:pPr>
+              <a:defRPr sz="1800"/>
+            </a:pPr>
+            <a:r>
+              <a:t>Key construct: interfaces define behavior across entity types (e.g., IIsSettlementTarget).</a:t>
+            </a:r>
+          </a:p>
+          <a:p>
+            <a:pPr>
+              <a:defRPr sz="1800"/>
+            </a:pPr>
+            <a:r>
+              <a:t>Vendor-hosted systems (TF/SCF) modeled via Containment Zone with progressive mapping.</a:t>
             </a:r>
           </a:p>
         </p:txBody>
@@ -4548,14 +3837,6 @@
 <file path=ppt/slides/slide4.xml><?xml version="1.0" encoding="utf-8"?>
 <p:sld xmlns:a="http://schemas.openxmlformats.org/drawingml/2006/main" xmlns:p="http://schemas.openxmlformats.org/presentationml/2006/main" xmlns:r="http://schemas.openxmlformats.org/officeDocument/2006/relationships">
   <p:cSld>
-    <p:bg>
-      <p:bgPr>
-        <a:solidFill>
-          <a:srgbClr val="FFFFFF"/>
-        </a:solidFill>
-        <a:effectLst/>
-      </p:bgPr>
-    </p:bg>
     <p:spTree>
       <p:nvGrpSpPr>
         <p:cNvPr id="1" name=""/>
@@ -4565,67 +3846,14 @@
       <p:grpSpPr/>
       <p:sp>
         <p:nvSpPr>
-          <p:cNvPr id="2" name="Rectangle 1"/>
-          <p:cNvSpPr/>
+          <p:cNvPr id="2" name="TextBox 1"/>
+          <p:cNvSpPr txBox="1"/>
           <p:nvPr/>
         </p:nvSpPr>
         <p:spPr>
           <a:xfrm>
-            <a:off x="0" y="0"/>
-            <a:ext cx="12188952" cy="777240"/>
-          </a:xfrm>
-          <a:prstGeom prst="rect">
-            <a:avLst/>
-          </a:prstGeom>
-          <a:solidFill>
-            <a:srgbClr val="0B3698"/>
-          </a:solidFill>
-          <a:ln>
-            <a:noFill/>
-          </a:ln>
-        </p:spPr>
-        <p:style>
-          <a:lnRef idx="1">
-            <a:schemeClr val="accent1"/>
-          </a:lnRef>
-          <a:fillRef idx="3">
-            <a:schemeClr val="accent1"/>
-          </a:fillRef>
-          <a:effectRef idx="2">
-            <a:schemeClr val="accent1"/>
-          </a:effectRef>
-          <a:fontRef idx="minor">
-            <a:schemeClr val="lt1"/>
-          </a:fontRef>
-        </p:style>
-        <p:txBody>
-          <a:bodyPr rtlCol="0" anchor="ctr" lIns="457200" tIns="109728"/>
-          <a:lstStyle/>
-          <a:p>
-            <a:pPr algn="l">
-              <a:defRPr sz="2600">
-                <a:solidFill>
-                  <a:srgbClr val="FFFFFF"/>
-                </a:solidFill>
-                <a:latin typeface="Calibri"/>
-              </a:defRPr>
-            </a:pPr>
-            <a:r>
-              <a:t>Dimension 2 — Materialization Strategy</a:t>
-            </a:r>
-          </a:p>
-        </p:txBody>
-      </p:sp>
-      <p:sp>
-        <p:nvSpPr>
-          <p:cNvPr id="3" name="TextBox 2"/>
-          <p:cNvSpPr txBox="1"/>
-          <p:nvPr/>
-        </p:nvSpPr>
-        <p:spPr>
-          <a:xfrm>
-            <a:off x="457200" y="347472"/>
-            <a:ext cx="9144000" cy="274320"/>
+            <a:off x="457200" y="365760"/>
+            <a:ext cx="8229600" cy="640080"/>
           </a:xfrm>
           <a:prstGeom prst="rect">
             <a:avLst/>
@@ -4638,73 +3866,25 @@
           </a:bodyPr>
           <a:lstStyle/>
           <a:p>
-            <a:pPr algn="l">
-              <a:defRPr sz="1300">
-                <a:solidFill>
-                  <a:srgbClr val="D9E7FC"/>
-                </a:solidFill>
-                <a:latin typeface="Calibri"/>
-              </a:defRPr>
-            </a:pPr>
-            <a:r>
-              <a:t>Where data lives and how it flows</a:t>
-            </a:r>
-          </a:p>
-        </p:txBody>
-      </p:sp>
-      <p:sp>
-        <p:nvSpPr>
-          <p:cNvPr id="4" name="Rectangle 3"/>
-          <p:cNvSpPr/>
+            <a:pPr>
+              <a:defRPr sz="2800" b="1"/>
+            </a:pPr>
+            <a:r>
+              <a:t>Dimension 2 — Materialization Strategy</a:t>
+            </a:r>
+          </a:p>
+        </p:txBody>
+      </p:sp>
+      <p:sp>
+        <p:nvSpPr>
+          <p:cNvPr id="3" name="TextBox 2"/>
+          <p:cNvSpPr txBox="1"/>
           <p:nvPr/>
         </p:nvSpPr>
         <p:spPr>
           <a:xfrm>
-            <a:off x="228600" y="1005840"/>
-            <a:ext cx="11731752" cy="5577840"/>
-          </a:xfrm>
-          <a:prstGeom prst="rect">
-            <a:avLst/>
-          </a:prstGeom>
-          <a:noFill/>
-          <a:ln w="12700">
-            <a:solidFill>
-              <a:srgbClr val="C0D0F0"/>
-            </a:solidFill>
-          </a:ln>
-        </p:spPr>
-        <p:style>
-          <a:lnRef idx="1">
-            <a:schemeClr val="accent1"/>
-          </a:lnRef>
-          <a:fillRef idx="3">
-            <a:schemeClr val="accent1"/>
-          </a:fillRef>
-          <a:effectRef idx="2">
-            <a:schemeClr val="accent1"/>
-          </a:effectRef>
-          <a:fontRef idx="minor">
-            <a:schemeClr val="lt1"/>
-          </a:fontRef>
-        </p:style>
-        <p:txBody>
-          <a:bodyPr rtlCol="0" anchor="ctr"/>
-          <a:lstStyle/>
-          <a:p>
-            <a:pPr algn="ctr"/>
-          </a:p>
-        </p:txBody>
-      </p:sp>
-      <p:sp>
-        <p:nvSpPr>
-          <p:cNvPr id="5" name="TextBox 4"/>
-          <p:cNvSpPr txBox="1"/>
-          <p:nvPr/>
-        </p:nvSpPr>
-        <p:spPr>
-          <a:xfrm>
-            <a:off x="548640" y="1097280"/>
-            <a:ext cx="10972800" cy="5029200"/>
+            <a:off x="457200" y="1188720"/>
+            <a:ext cx="8229600" cy="5486400"/>
           </a:xfrm>
           <a:prstGeom prst="rect">
             <a:avLst/>
@@ -4718,97 +3898,42 @@
           <a:lstStyle/>
           <a:p>
             <a:pPr>
-              <a:spcBef>
-                <a:spcPts val="200"/>
-              </a:spcBef>
-              <a:spcAft>
-                <a:spcPts val="300"/>
-              </a:spcAft>
-            </a:pPr>
-            <a:r>
-              <a:rPr sz="1700">
-                <a:solidFill>
-                  <a:srgbClr val="1A1A1A"/>
-                </a:solidFill>
-                <a:latin typeface="Calibri"/>
-              </a:rPr>
-              <a:t>• Neo4j: operational graph — real-time traversals, ownership chains, entitlement resolution.</a:t>
-            </a:r>
-          </a:p>
-          <a:p>
-            <a:pPr>
-              <a:spcBef>
-                <a:spcPts val="200"/>
-              </a:spcBef>
-              <a:spcAft>
-                <a:spcPts val="300"/>
-              </a:spcAft>
-            </a:pPr>
-            <a:r>
-              <a:rPr sz="1700">
-                <a:solidFill>
-                  <a:srgbClr val="1A1A1A"/>
-                </a:solidFill>
-                <a:latin typeface="Calibri"/>
-              </a:rPr>
-              <a:t>• PostgreSQL: kinetic layer + proof + mandates — ACID, append-only, hash-chained, fast reads.</a:t>
-            </a:r>
-          </a:p>
-          <a:p>
-            <a:pPr>
-              <a:spcBef>
-                <a:spcPts val="200"/>
-              </a:spcBef>
-              <a:spcAft>
-                <a:spcPts val="300"/>
-              </a:spcAft>
-            </a:pPr>
-            <a:r>
-              <a:rPr sz="1700">
-                <a:solidFill>
-                  <a:srgbClr val="1A1A1A"/>
-                </a:solidFill>
-                <a:latin typeface="Calibri"/>
-              </a:rPr>
-              <a:t>• Delta Lake (Databricks): analytics, temporal history, LOB projections, containment zone.</a:t>
-            </a:r>
-          </a:p>
-          <a:p>
-            <a:pPr>
-              <a:spcBef>
-                <a:spcPts val="200"/>
-              </a:spcBef>
-              <a:spcAft>
-                <a:spcPts val="300"/>
-              </a:spcAft>
-            </a:pPr>
-            <a:r>
-              <a:rPr sz="1700">
-                <a:solidFill>
-                  <a:srgbClr val="1A1A1A"/>
-                </a:solidFill>
-                <a:latin typeface="Calibri"/>
-              </a:rPr>
-              <a:t>• Redis: hot cache for entitlements, mandates, high-frequency lookups; invalidation via streams.</a:t>
-            </a:r>
-          </a:p>
-          <a:p>
-            <a:pPr>
-              <a:spcBef>
-                <a:spcPts val="200"/>
-              </a:spcBef>
-              <a:spcAft>
-                <a:spcPts val="300"/>
-              </a:spcAft>
-            </a:pPr>
-            <a:r>
-              <a:rPr sz="1700">
-                <a:solidFill>
-                  <a:srgbClr val="1A1A1A"/>
-                </a:solidFill>
-                <a:latin typeface="Calibri"/>
-              </a:rPr>
-              <a:t>• Cross-store sync via CDC (Confluent/Kafka); graph is always the source of truth.</a:t>
+              <a:defRPr sz="1800"/>
+            </a:pPr>
+            <a:r>
+              <a:t>Neo4j: operational graph for real-time traversals, ownership, entitlement checks.</a:t>
+            </a:r>
+          </a:p>
+          <a:p>
+            <a:pPr>
+              <a:defRPr sz="1800"/>
+            </a:pPr>
+            <a:r>
+              <a:t>PostgreSQL: kinetic layer, mandates, and append-only proof registry.</a:t>
+            </a:r>
+          </a:p>
+          <a:p>
+            <a:pPr>
+              <a:defRPr sz="1800"/>
+            </a:pPr>
+            <a:r>
+              <a:t>Delta Lake (Databricks): analytics, history, LOB projections, containment zone.</a:t>
+            </a:r>
+          </a:p>
+          <a:p>
+            <a:pPr>
+              <a:defRPr sz="1800"/>
+            </a:pPr>
+            <a:r>
+              <a:t>Redis: hot cache for entitlements, mandates, high-frequency lookups.</a:t>
+            </a:r>
+          </a:p>
+          <a:p>
+            <a:pPr>
+              <a:defRPr sz="1800"/>
+            </a:pPr>
+            <a:r>
+              <a:t>Cross-store sync via CDC (Confluent); graph is always the source of truth.</a:t>
             </a:r>
           </a:p>
         </p:txBody>
@@ -4824,14 +3949,6 @@
 <file path=ppt/slides/slide5.xml><?xml version="1.0" encoding="utf-8"?>
 <p:sld xmlns:a="http://schemas.openxmlformats.org/drawingml/2006/main" xmlns:p="http://schemas.openxmlformats.org/presentationml/2006/main" xmlns:r="http://schemas.openxmlformats.org/officeDocument/2006/relationships">
   <p:cSld>
-    <p:bg>
-      <p:bgPr>
-        <a:solidFill>
-          <a:srgbClr val="FFFFFF"/>
-        </a:solidFill>
-        <a:effectLst/>
-      </p:bgPr>
-    </p:bg>
     <p:spTree>
       <p:nvGrpSpPr>
         <p:cNvPr id="1" name=""/>
@@ -4841,67 +3958,14 @@
       <p:grpSpPr/>
       <p:sp>
         <p:nvSpPr>
-          <p:cNvPr id="2" name="Rectangle 1"/>
-          <p:cNvSpPr/>
+          <p:cNvPr id="2" name="TextBox 1"/>
+          <p:cNvSpPr txBox="1"/>
           <p:nvPr/>
         </p:nvSpPr>
         <p:spPr>
           <a:xfrm>
-            <a:off x="0" y="0"/>
-            <a:ext cx="12188952" cy="777240"/>
-          </a:xfrm>
-          <a:prstGeom prst="rect">
-            <a:avLst/>
-          </a:prstGeom>
-          <a:solidFill>
-            <a:srgbClr val="0B3698"/>
-          </a:solidFill>
-          <a:ln>
-            <a:noFill/>
-          </a:ln>
-        </p:spPr>
-        <p:style>
-          <a:lnRef idx="1">
-            <a:schemeClr val="accent1"/>
-          </a:lnRef>
-          <a:fillRef idx="3">
-            <a:schemeClr val="accent1"/>
-          </a:fillRef>
-          <a:effectRef idx="2">
-            <a:schemeClr val="accent1"/>
-          </a:effectRef>
-          <a:fontRef idx="minor">
-            <a:schemeClr val="lt1"/>
-          </a:fontRef>
-        </p:style>
-        <p:txBody>
-          <a:bodyPr rtlCol="0" anchor="ctr" lIns="457200" tIns="109728"/>
-          <a:lstStyle/>
-          <a:p>
-            <a:pPr algn="l">
-              <a:defRPr sz="2600">
-                <a:solidFill>
-                  <a:srgbClr val="FFFFFF"/>
-                </a:solidFill>
-                <a:latin typeface="Calibri"/>
-              </a:defRPr>
-            </a:pPr>
-            <a:r>
-              <a:t>Dimension 3 — Platform Infrastructure</a:t>
-            </a:r>
-          </a:p>
-        </p:txBody>
-      </p:sp>
-      <p:sp>
-        <p:nvSpPr>
-          <p:cNvPr id="3" name="TextBox 2"/>
-          <p:cNvSpPr txBox="1"/>
-          <p:nvPr/>
-        </p:nvSpPr>
-        <p:spPr>
-          <a:xfrm>
-            <a:off x="457200" y="347472"/>
-            <a:ext cx="9144000" cy="274320"/>
+            <a:off x="457200" y="365760"/>
+            <a:ext cx="8229600" cy="640080"/>
           </a:xfrm>
           <a:prstGeom prst="rect">
             <a:avLst/>
@@ -4914,73 +3978,25 @@
           </a:bodyPr>
           <a:lstStyle/>
           <a:p>
-            <a:pPr algn="l">
-              <a:defRPr sz="1300">
-                <a:solidFill>
-                  <a:srgbClr val="D9E7FC"/>
-                </a:solidFill>
-                <a:latin typeface="Calibri"/>
-              </a:defRPr>
-            </a:pPr>
-            <a:r>
-              <a:t>Cohesive runtime: streaming, compute, storage</a:t>
-            </a:r>
-          </a:p>
-        </p:txBody>
-      </p:sp>
-      <p:sp>
-        <p:nvSpPr>
-          <p:cNvPr id="4" name="Rectangle 3"/>
-          <p:cNvSpPr/>
+            <a:pPr>
+              <a:defRPr sz="2800" b="1"/>
+            </a:pPr>
+            <a:r>
+              <a:t>Dimension 3 — Platform Infrastructure</a:t>
+            </a:r>
+          </a:p>
+        </p:txBody>
+      </p:sp>
+      <p:sp>
+        <p:nvSpPr>
+          <p:cNvPr id="3" name="TextBox 2"/>
+          <p:cNvSpPr txBox="1"/>
           <p:nvPr/>
         </p:nvSpPr>
         <p:spPr>
           <a:xfrm>
-            <a:off x="228600" y="1005840"/>
-            <a:ext cx="11731752" cy="5577840"/>
-          </a:xfrm>
-          <a:prstGeom prst="rect">
-            <a:avLst/>
-          </a:prstGeom>
-          <a:noFill/>
-          <a:ln w="12700">
-            <a:solidFill>
-              <a:srgbClr val="C0D0F0"/>
-            </a:solidFill>
-          </a:ln>
-        </p:spPr>
-        <p:style>
-          <a:lnRef idx="1">
-            <a:schemeClr val="accent1"/>
-          </a:lnRef>
-          <a:fillRef idx="3">
-            <a:schemeClr val="accent1"/>
-          </a:fillRef>
-          <a:effectRef idx="2">
-            <a:schemeClr val="accent1"/>
-          </a:effectRef>
-          <a:fontRef idx="minor">
-            <a:schemeClr val="lt1"/>
-          </a:fontRef>
-        </p:style>
-        <p:txBody>
-          <a:bodyPr rtlCol="0" anchor="ctr"/>
-          <a:lstStyle/>
-          <a:p>
-            <a:pPr algn="ctr"/>
-          </a:p>
-        </p:txBody>
-      </p:sp>
-      <p:sp>
-        <p:nvSpPr>
-          <p:cNvPr id="5" name="TextBox 4"/>
-          <p:cNvSpPr txBox="1"/>
-          <p:nvPr/>
-        </p:nvSpPr>
-        <p:spPr>
-          <a:xfrm>
-            <a:off x="548640" y="1097280"/>
-            <a:ext cx="10972800" cy="5029200"/>
+            <a:off x="457200" y="1188720"/>
+            <a:ext cx="8229600" cy="5486400"/>
           </a:xfrm>
           <a:prstGeom prst="rect">
             <a:avLst/>
@@ -4994,97 +4010,42 @@
           <a:lstStyle/>
           <a:p>
             <a:pPr>
-              <a:spcBef>
-                <a:spcPts val="200"/>
-              </a:spcBef>
-              <a:spcAft>
-                <a:spcPts val="300"/>
-              </a:spcAft>
-            </a:pPr>
-            <a:r>
-              <a:rPr sz="1700">
-                <a:solidFill>
-                  <a:srgbClr val="1A1A1A"/>
-                </a:solidFill>
-                <a:latin typeface="Calibri"/>
-              </a:rPr>
-              <a:t>• Confluent Cloud (Dedicated) on Azure: canonical streaming backbone (CDC, kinetic, vendor, governance).</a:t>
-            </a:r>
-          </a:p>
-          <a:p>
-            <a:pPr>
-              <a:spcBef>
-                <a:spcPts val="200"/>
-              </a:spcBef>
-              <a:spcAft>
-                <a:spcPts val="300"/>
-              </a:spcAft>
-            </a:pPr>
-            <a:r>
-              <a:rPr sz="1700">
-                <a:solidFill>
-                  <a:srgbClr val="1A1A1A"/>
-                </a:solidFill>
-                <a:latin typeface="Calibri"/>
-              </a:rPr>
-              <a:t>• Flink on Kubernetes (AKS): stateful stream computing — CEP, rule enforcement, forecasting, liquidity.</a:t>
-            </a:r>
-          </a:p>
-          <a:p>
-            <a:pPr>
-              <a:spcBef>
-                <a:spcPts val="200"/>
-              </a:spcBef>
-              <a:spcAft>
-                <a:spcPts val="300"/>
-              </a:spcAft>
-            </a:pPr>
-            <a:r>
-              <a:rPr sz="1700">
-                <a:solidFill>
-                  <a:srgbClr val="1A1A1A"/>
-                </a:solidFill>
-                <a:latin typeface="Calibri"/>
-              </a:rPr>
-              <a:t>• Neo4j + PostgreSQL: optimized for graph traversal and ACID kinetic/proof workloads.</a:t>
-            </a:r>
-          </a:p>
-          <a:p>
-            <a:pPr>
-              <a:spcBef>
-                <a:spcPts val="200"/>
-              </a:spcBef>
-              <a:spcAft>
-                <a:spcPts val="300"/>
-              </a:spcAft>
-            </a:pPr>
-            <a:r>
-              <a:rPr sz="1700">
-                <a:solidFill>
-                  <a:srgbClr val="1A1A1A"/>
-                </a:solidFill>
-                <a:latin typeface="Calibri"/>
-              </a:rPr>
-              <a:t>• Databricks / Delta Lake: analytics, history, LOB projections, regulatory reports.</a:t>
-            </a:r>
-          </a:p>
-          <a:p>
-            <a:pPr>
-              <a:spcBef>
-                <a:spcPts val="200"/>
-              </a:spcBef>
-              <a:spcAft>
-                <a:spcPts val="300"/>
-              </a:spcAft>
-            </a:pPr>
-            <a:r>
-              <a:rPr sz="1700">
-                <a:solidFill>
-                  <a:srgbClr val="1A1A1A"/>
-                </a:solidFill>
-                <a:latin typeface="Calibri"/>
-              </a:rPr>
-              <a:t>• Azure-native networking, TLS, private endpoints, Unity Catalog governance across the stack.</a:t>
+              <a:defRPr sz="1800"/>
+            </a:pPr>
+            <a:r>
+              <a:t>Confluent Cloud (Dedicated): canonical streaming backbone (CDC, kinetic, vendor, governance).</a:t>
+            </a:r>
+          </a:p>
+          <a:p>
+            <a:pPr>
+              <a:defRPr sz="1800"/>
+            </a:pPr>
+            <a:r>
+              <a:t>Flink on Kubernetes (AKS): stateful stream computing for correlation, CEP, forecasting.</a:t>
+            </a:r>
+          </a:p>
+          <a:p>
+            <a:pPr>
+              <a:defRPr sz="1800"/>
+            </a:pPr>
+            <a:r>
+              <a:t>Neo4j + PostgreSQL: optimized for graph traversal and ACID kinetic/proof workloads.</a:t>
+            </a:r>
+          </a:p>
+          <a:p>
+            <a:pPr>
+              <a:defRPr sz="1800"/>
+            </a:pPr>
+            <a:r>
+              <a:t>Databricks/Delta Lake: analytics, history, regulatory reports.</a:t>
+            </a:r>
+          </a:p>
+          <a:p>
+            <a:pPr>
+              <a:defRPr sz="1800"/>
+            </a:pPr>
+            <a:r>
+              <a:t>Azure-native: private endpoints, TLS, Unity Catalog governance.</a:t>
             </a:r>
           </a:p>
         </p:txBody>
@@ -5100,14 +4061,6 @@
 <file path=ppt/slides/slide6.xml><?xml version="1.0" encoding="utf-8"?>
 <p:sld xmlns:a="http://schemas.openxmlformats.org/drawingml/2006/main" xmlns:p="http://schemas.openxmlformats.org/presentationml/2006/main" xmlns:r="http://schemas.openxmlformats.org/officeDocument/2006/relationships">
   <p:cSld>
-    <p:bg>
-      <p:bgPr>
-        <a:solidFill>
-          <a:srgbClr val="FFFFFF"/>
-        </a:solidFill>
-        <a:effectLst/>
-      </p:bgPr>
-    </p:bg>
     <p:spTree>
       <p:nvGrpSpPr>
         <p:cNvPr id="1" name=""/>
@@ -5117,67 +4070,14 @@
       <p:grpSpPr/>
       <p:sp>
         <p:nvSpPr>
-          <p:cNvPr id="2" name="Rectangle 1"/>
-          <p:cNvSpPr/>
+          <p:cNvPr id="2" name="TextBox 1"/>
+          <p:cNvSpPr txBox="1"/>
           <p:nvPr/>
         </p:nvSpPr>
         <p:spPr>
           <a:xfrm>
-            <a:off x="0" y="0"/>
-            <a:ext cx="12188952" cy="777240"/>
-          </a:xfrm>
-          <a:prstGeom prst="rect">
-            <a:avLst/>
-          </a:prstGeom>
-          <a:solidFill>
-            <a:srgbClr val="0B3698"/>
-          </a:solidFill>
-          <a:ln>
-            <a:noFill/>
-          </a:ln>
-        </p:spPr>
-        <p:style>
-          <a:lnRef idx="1">
-            <a:schemeClr val="accent1"/>
-          </a:lnRef>
-          <a:fillRef idx="3">
-            <a:schemeClr val="accent1"/>
-          </a:fillRef>
-          <a:effectRef idx="2">
-            <a:schemeClr val="accent1"/>
-          </a:effectRef>
-          <a:fontRef idx="minor">
-            <a:schemeClr val="lt1"/>
-          </a:fontRef>
-        </p:style>
-        <p:txBody>
-          <a:bodyPr rtlCol="0" anchor="ctr" lIns="457200" tIns="109728"/>
-          <a:lstStyle/>
-          <a:p>
-            <a:pPr algn="l">
-              <a:defRPr sz="2600">
-                <a:solidFill>
-                  <a:srgbClr val="FFFFFF"/>
-                </a:solidFill>
-                <a:latin typeface="Calibri"/>
-              </a:defRPr>
-            </a:pPr>
-            <a:r>
-              <a:t>Dimension 4 — API &amp; Integration Contract</a:t>
-            </a:r>
-          </a:p>
-        </p:txBody>
-      </p:sp>
-      <p:sp>
-        <p:nvSpPr>
-          <p:cNvPr id="3" name="TextBox 2"/>
-          <p:cNvSpPr txBox="1"/>
-          <p:nvPr/>
-        </p:nvSpPr>
-        <p:spPr>
-          <a:xfrm>
-            <a:off x="457200" y="347472"/>
-            <a:ext cx="9144000" cy="274320"/>
+            <a:off x="457200" y="365760"/>
+            <a:ext cx="8229600" cy="640080"/>
           </a:xfrm>
           <a:prstGeom prst="rect">
             <a:avLst/>
@@ -5190,73 +4090,25 @@
           </a:bodyPr>
           <a:lstStyle/>
           <a:p>
-            <a:pPr algn="l">
-              <a:defRPr sz="1300">
-                <a:solidFill>
-                  <a:srgbClr val="D9E7FC"/>
-                </a:solidFill>
-                <a:latin typeface="Calibri"/>
-              </a:defRPr>
-            </a:pPr>
-            <a:r>
-              <a:t>Entity Platform API as the ontology action surface</a:t>
-            </a:r>
-          </a:p>
-        </p:txBody>
-      </p:sp>
-      <p:sp>
-        <p:nvSpPr>
-          <p:cNvPr id="4" name="Rectangle 3"/>
-          <p:cNvSpPr/>
+            <a:pPr>
+              <a:defRPr sz="2800" b="1"/>
+            </a:pPr>
+            <a:r>
+              <a:t>Dimension 4 — API &amp; Integration Contract</a:t>
+            </a:r>
+          </a:p>
+        </p:txBody>
+      </p:sp>
+      <p:sp>
+        <p:nvSpPr>
+          <p:cNvPr id="3" name="TextBox 2"/>
+          <p:cNvSpPr txBox="1"/>
           <p:nvPr/>
         </p:nvSpPr>
         <p:spPr>
           <a:xfrm>
-            <a:off x="228600" y="1005840"/>
-            <a:ext cx="11731752" cy="5577840"/>
-          </a:xfrm>
-          <a:prstGeom prst="rect">
-            <a:avLst/>
-          </a:prstGeom>
-          <a:noFill/>
-          <a:ln w="12700">
-            <a:solidFill>
-              <a:srgbClr val="C0D0F0"/>
-            </a:solidFill>
-          </a:ln>
-        </p:spPr>
-        <p:style>
-          <a:lnRef idx="1">
-            <a:schemeClr val="accent1"/>
-          </a:lnRef>
-          <a:fillRef idx="3">
-            <a:schemeClr val="accent1"/>
-          </a:fillRef>
-          <a:effectRef idx="2">
-            <a:schemeClr val="accent1"/>
-          </a:effectRef>
-          <a:fontRef idx="minor">
-            <a:schemeClr val="lt1"/>
-          </a:fontRef>
-        </p:style>
-        <p:txBody>
-          <a:bodyPr rtlCol="0" anchor="ctr"/>
-          <a:lstStyle/>
-          <a:p>
-            <a:pPr algn="ctr"/>
-          </a:p>
-        </p:txBody>
-      </p:sp>
-      <p:sp>
-        <p:nvSpPr>
-          <p:cNvPr id="5" name="TextBox 4"/>
-          <p:cNvSpPr txBox="1"/>
-          <p:nvPr/>
-        </p:nvSpPr>
-        <p:spPr>
-          <a:xfrm>
-            <a:off x="548640" y="1097280"/>
-            <a:ext cx="10972800" cy="5029200"/>
+            <a:off x="457200" y="1188720"/>
+            <a:ext cx="8229600" cy="5486400"/>
           </a:xfrm>
           <a:prstGeom prst="rect">
             <a:avLst/>
@@ -5270,97 +4122,42 @@
           <a:lstStyle/>
           <a:p>
             <a:pPr>
-              <a:spcBef>
-                <a:spcPts val="200"/>
-              </a:spcBef>
-              <a:spcAft>
-                <a:spcPts val="300"/>
-              </a:spcAft>
-            </a:pPr>
-            <a:r>
-              <a:rPr sz="1700">
-                <a:solidFill>
-                  <a:srgbClr val="1A1A1A"/>
-                </a:solidFill>
-                <a:latin typeface="Calibri"/>
-              </a:rPr>
-              <a:t>• Entity Platform API is the sole write path — no direct CRUD on canonical stores.</a:t>
-            </a:r>
-          </a:p>
-          <a:p>
-            <a:pPr>
-              <a:spcBef>
-                <a:spcPts val="200"/>
-              </a:spcBef>
-              <a:spcAft>
-                <a:spcPts val="300"/>
-              </a:spcAft>
-            </a:pPr>
-            <a:r>
-              <a:rPr sz="1700">
-                <a:solidFill>
-                  <a:srgbClr val="1A1A1A"/>
-                </a:solidFill>
-                <a:latin typeface="Calibri"/>
-              </a:rPr>
-              <a:t>• Endpoints are ontology actions: InitiatePayment, ExecuteFXForward, DrawdownFacility, etc.</a:t>
-            </a:r>
-          </a:p>
-          <a:p>
-            <a:pPr>
-              <a:spcBef>
-                <a:spcPts val="200"/>
-              </a:spcBef>
-              <a:spcAft>
-                <a:spcPts val="300"/>
-              </a:spcAft>
-            </a:pPr>
-            <a:r>
-              <a:rPr sz="1700">
-                <a:solidFill>
-                  <a:srgbClr val="1A1A1A"/>
-                </a:solidFill>
-                <a:latin typeface="Calibri"/>
-              </a:rPr>
-              <a:t>• Every write includes a proof payload; rejects if proof or authority is missing.</a:t>
-            </a:r>
-          </a:p>
-          <a:p>
-            <a:pPr>
-              <a:spcBef>
-                <a:spcPts val="200"/>
-              </a:spcBef>
-              <a:spcAft>
-                <a:spcPts val="300"/>
-              </a:spcAft>
-            </a:pPr>
-            <a:r>
-              <a:rPr sz="1700">
-                <a:solidFill>
-                  <a:srgbClr val="1A1A1A"/>
-                </a:solidFill>
-                <a:latin typeface="Calibri"/>
-              </a:rPr>
-              <a:t>• Async via Confluent: domain, kinetic, vendor, governance events consumed by analytics, risk, vendors.</a:t>
-            </a:r>
-          </a:p>
-          <a:p>
-            <a:pPr>
-              <a:spcBef>
-                <a:spcPts val="200"/>
-              </a:spcBef>
-              <a:spcAft>
-                <a:spcPts val="300"/>
-              </a:spcAft>
-            </a:pPr>
-            <a:r>
-              <a:rPr sz="1700">
-                <a:solidFill>
-                  <a:srgbClr val="1A1A1A"/>
-                </a:solidFill>
-                <a:latin typeface="Calibri"/>
-              </a:rPr>
-              <a:t>• LOBs and partners integrate via API (sync) + selected Kafka topics (async, governed).</a:t>
+              <a:defRPr sz="1800"/>
+            </a:pPr>
+            <a:r>
+              <a:t>Entity Platform API is the sole write path to the canonical platform.</a:t>
+            </a:r>
+          </a:p>
+          <a:p>
+            <a:pPr>
+              <a:defRPr sz="1800"/>
+            </a:pPr>
+            <a:r>
+              <a:t>Endpoints are ontology actions (InitiatePayment, ExecuteFXForward, etc.), not raw CRUD.</a:t>
+            </a:r>
+          </a:p>
+          <a:p>
+            <a:pPr>
+              <a:defRPr sz="1800"/>
+            </a:pPr>
+            <a:r>
+              <a:t>Every write includes a proof payload; rejected if missing or invalid.</a:t>
+            </a:r>
+          </a:p>
+          <a:p>
+            <a:pPr>
+              <a:defRPr sz="1800"/>
+            </a:pPr>
+            <a:r>
+              <a:t>Async via Confluent: domain, kinetic, vendor, and governance events for analytics, risk, vendors.</a:t>
+            </a:r>
+          </a:p>
+          <a:p>
+            <a:pPr>
+              <a:defRPr sz="1800"/>
+            </a:pPr>
+            <a:r>
+              <a:t>LOBs and partners integrate via API (sync) + governed Kafka topics (async).</a:t>
             </a:r>
           </a:p>
         </p:txBody>
@@ -5376,14 +4173,6 @@
 <file path=ppt/slides/slide7.xml><?xml version="1.0" encoding="utf-8"?>
 <p:sld xmlns:a="http://schemas.openxmlformats.org/drawingml/2006/main" xmlns:p="http://schemas.openxmlformats.org/presentationml/2006/main" xmlns:r="http://schemas.openxmlformats.org/officeDocument/2006/relationships">
   <p:cSld>
-    <p:bg>
-      <p:bgPr>
-        <a:solidFill>
-          <a:srgbClr val="FFFFFF"/>
-        </a:solidFill>
-        <a:effectLst/>
-      </p:bgPr>
-    </p:bg>
     <p:spTree>
       <p:nvGrpSpPr>
         <p:cNvPr id="1" name=""/>
@@ -5393,67 +4182,14 @@
       <p:grpSpPr/>
       <p:sp>
         <p:nvSpPr>
-          <p:cNvPr id="2" name="Rectangle 1"/>
-          <p:cNvSpPr/>
+          <p:cNvPr id="2" name="TextBox 1"/>
+          <p:cNvSpPr txBox="1"/>
           <p:nvPr/>
         </p:nvSpPr>
         <p:spPr>
           <a:xfrm>
-            <a:off x="0" y="0"/>
-            <a:ext cx="12188952" cy="777240"/>
-          </a:xfrm>
-          <a:prstGeom prst="rect">
-            <a:avLst/>
-          </a:prstGeom>
-          <a:solidFill>
-            <a:srgbClr val="0B3698"/>
-          </a:solidFill>
-          <a:ln>
-            <a:noFill/>
-          </a:ln>
-        </p:spPr>
-        <p:style>
-          <a:lnRef idx="1">
-            <a:schemeClr val="accent1"/>
-          </a:lnRef>
-          <a:fillRef idx="3">
-            <a:schemeClr val="accent1"/>
-          </a:fillRef>
-          <a:effectRef idx="2">
-            <a:schemeClr val="accent1"/>
-          </a:effectRef>
-          <a:fontRef idx="minor">
-            <a:schemeClr val="lt1"/>
-          </a:fontRef>
-        </p:style>
-        <p:txBody>
-          <a:bodyPr rtlCol="0" anchor="ctr" lIns="457200" tIns="109728"/>
-          <a:lstStyle/>
-          <a:p>
-            <a:pPr algn="l">
-              <a:defRPr sz="2600">
-                <a:solidFill>
-                  <a:srgbClr val="FFFFFF"/>
-                </a:solidFill>
-                <a:latin typeface="Calibri"/>
-              </a:defRPr>
-            </a:pPr>
-            <a:r>
-              <a:t>Dimension 5 — Governance, Trust, Mandates</a:t>
-            </a:r>
-          </a:p>
-        </p:txBody>
-      </p:sp>
-      <p:sp>
-        <p:nvSpPr>
-          <p:cNvPr id="3" name="TextBox 2"/>
-          <p:cNvSpPr txBox="1"/>
-          <p:nvPr/>
-        </p:nvSpPr>
-        <p:spPr>
-          <a:xfrm>
-            <a:off x="457200" y="347472"/>
-            <a:ext cx="9144000" cy="274320"/>
+            <a:off x="457200" y="365760"/>
+            <a:ext cx="8229600" cy="640080"/>
           </a:xfrm>
           <a:prstGeom prst="rect">
             <a:avLst/>
@@ -5466,73 +4202,25 @@
           </a:bodyPr>
           <a:lstStyle/>
           <a:p>
-            <a:pPr algn="l">
-              <a:defRPr sz="1300">
-                <a:solidFill>
-                  <a:srgbClr val="D9E7FC"/>
-                </a:solidFill>
-                <a:latin typeface="Calibri"/>
-              </a:defRPr>
-            </a:pPr>
-            <a:r>
-              <a:t>Trust is engineered, not assumed</a:t>
-            </a:r>
-          </a:p>
-        </p:txBody>
-      </p:sp>
-      <p:sp>
-        <p:nvSpPr>
-          <p:cNvPr id="4" name="Rectangle 3"/>
-          <p:cNvSpPr/>
+            <a:pPr>
+              <a:defRPr sz="2800" b="1"/>
+            </a:pPr>
+            <a:r>
+              <a:t>Dimension 5 — Governance, Trust, Mandates</a:t>
+            </a:r>
+          </a:p>
+        </p:txBody>
+      </p:sp>
+      <p:sp>
+        <p:nvSpPr>
+          <p:cNvPr id="3" name="TextBox 2"/>
+          <p:cNvSpPr txBox="1"/>
           <p:nvPr/>
         </p:nvSpPr>
         <p:spPr>
           <a:xfrm>
-            <a:off x="228600" y="1005840"/>
-            <a:ext cx="11731752" cy="5577840"/>
-          </a:xfrm>
-          <a:prstGeom prst="rect">
-            <a:avLst/>
-          </a:prstGeom>
-          <a:noFill/>
-          <a:ln w="12700">
-            <a:solidFill>
-              <a:srgbClr val="C0D0F0"/>
-            </a:solidFill>
-          </a:ln>
-        </p:spPr>
-        <p:style>
-          <a:lnRef idx="1">
-            <a:schemeClr val="accent1"/>
-          </a:lnRef>
-          <a:fillRef idx="3">
-            <a:schemeClr val="accent1"/>
-          </a:fillRef>
-          <a:effectRef idx="2">
-            <a:schemeClr val="accent1"/>
-          </a:effectRef>
-          <a:fontRef idx="minor">
-            <a:schemeClr val="lt1"/>
-          </a:fontRef>
-        </p:style>
-        <p:txBody>
-          <a:bodyPr rtlCol="0" anchor="ctr"/>
-          <a:lstStyle/>
-          <a:p>
-            <a:pPr algn="ctr"/>
-          </a:p>
-        </p:txBody>
-      </p:sp>
-      <p:sp>
-        <p:nvSpPr>
-          <p:cNvPr id="5" name="TextBox 4"/>
-          <p:cNvSpPr txBox="1"/>
-          <p:nvPr/>
-        </p:nvSpPr>
-        <p:spPr>
-          <a:xfrm>
-            <a:off x="548640" y="1097280"/>
-            <a:ext cx="10972800" cy="5029200"/>
+            <a:off x="457200" y="1188720"/>
+            <a:ext cx="8229600" cy="5486400"/>
           </a:xfrm>
           <a:prstGeom prst="rect">
             <a:avLst/>
@@ -5546,97 +4234,42 @@
           <a:lstStyle/>
           <a:p>
             <a:pPr>
-              <a:spcBef>
-                <a:spcPts val="200"/>
-              </a:spcBef>
-              <a:spcAft>
-                <a:spcPts val="300"/>
-              </a:spcAft>
-            </a:pPr>
-            <a:r>
-              <a:rPr sz="1700">
-                <a:solidFill>
-                  <a:srgbClr val="1A1A1A"/>
-                </a:solidFill>
-                <a:latin typeface="Calibri"/>
-              </a:rPr>
-              <a:t>• Mandate hierarchy: HumanMandate → SystemMandate → AgentMandate.</a:t>
-            </a:r>
-          </a:p>
-          <a:p>
-            <a:pPr>
-              <a:spcBef>
-                <a:spcPts val="200"/>
-              </a:spcBef>
-              <a:spcAft>
-                <a:spcPts val="300"/>
-              </a:spcAft>
-            </a:pPr>
-            <a:r>
-              <a:rPr sz="1700">
-                <a:solidFill>
-                  <a:srgbClr val="1A1A1A"/>
-                </a:solidFill>
-                <a:latin typeface="Calibri"/>
-              </a:rPr>
-              <a:t>• No agent action executes without a valid mandate and intact delegation chain.</a:t>
-            </a:r>
-          </a:p>
-          <a:p>
-            <a:pPr>
-              <a:spcBef>
-                <a:spcPts val="200"/>
-              </a:spcBef>
-              <a:spcAft>
-                <a:spcPts val="300"/>
-              </a:spcAft>
-            </a:pPr>
-            <a:r>
-              <a:rPr sz="1700">
-                <a:solidFill>
-                  <a:srgbClr val="1A1A1A"/>
-                </a:solidFill>
-                <a:latin typeface="Calibri"/>
-              </a:rPr>
-              <a:t>• Proof registry: append-only, SHA-256 chained; every edge has an evidentiary trail.</a:t>
-            </a:r>
-          </a:p>
-          <a:p>
-            <a:pPr>
-              <a:spcBef>
-                <a:spcPts val="200"/>
-              </a:spcBef>
-              <a:spcAft>
-                <a:spcPts val="300"/>
-              </a:spcAft>
-            </a:pPr>
-            <a:r>
-              <a:rPr sz="1700">
-                <a:solidFill>
-                  <a:srgbClr val="1A1A1A"/>
-                </a:solidFill>
-                <a:latin typeface="Calibri"/>
-              </a:rPr>
-              <a:t>• All kinetic and Flink decisions logged as governance.audit-events in streams.</a:t>
-            </a:r>
-          </a:p>
-          <a:p>
-            <a:pPr>
-              <a:spcBef>
-                <a:spcPts val="200"/>
-              </a:spcBef>
-              <a:spcAft>
-                <a:spcPts val="300"/>
-              </a:spcAft>
-            </a:pPr>
-            <a:r>
-              <a:rPr sz="1700">
-                <a:solidFill>
-                  <a:srgbClr val="1A1A1A"/>
-                </a:solidFill>
-                <a:latin typeface="Calibri"/>
-              </a:rPr>
-              <a:t>• Reconstructible: regulators can see exactly what the system saw and decided.</a:t>
+              <a:defRPr sz="1800"/>
+            </a:pPr>
+            <a:r>
+              <a:t>Mandate hierarchy: HumanMandate → SystemMandate → AgentMandate.</a:t>
+            </a:r>
+          </a:p>
+          <a:p>
+            <a:pPr>
+              <a:defRPr sz="1800"/>
+            </a:pPr>
+            <a:r>
+              <a:t>No agent action executes without a valid mandate and intact delegation chain.</a:t>
+            </a:r>
+          </a:p>
+          <a:p>
+            <a:pPr>
+              <a:defRPr sz="1800"/>
+            </a:pPr>
+            <a:r>
+              <a:t>Proof registry: append-only, SHA-256 chained; every edge has an evidentiary trail.</a:t>
+            </a:r>
+          </a:p>
+          <a:p>
+            <a:pPr>
+              <a:defRPr sz="1800"/>
+            </a:pPr>
+            <a:r>
+              <a:t>All kinetic and Flink decisions logged as governance.audit-events in streaming layers.</a:t>
+            </a:r>
+          </a:p>
+          <a:p>
+            <a:pPr>
+              <a:defRPr sz="1800"/>
+            </a:pPr>
+            <a:r>
+              <a:t>Fully reconstructible for regulators and internal audits.</a:t>
             </a:r>
           </a:p>
         </p:txBody>
@@ -5652,14 +4285,6 @@
 <file path=ppt/slides/slide8.xml><?xml version="1.0" encoding="utf-8"?>
 <p:sld xmlns:a="http://schemas.openxmlformats.org/drawingml/2006/main" xmlns:p="http://schemas.openxmlformats.org/presentationml/2006/main" xmlns:r="http://schemas.openxmlformats.org/officeDocument/2006/relationships">
   <p:cSld>
-    <p:bg>
-      <p:bgPr>
-        <a:solidFill>
-          <a:srgbClr val="FFFFFF"/>
-        </a:solidFill>
-        <a:effectLst/>
-      </p:bgPr>
-    </p:bg>
     <p:spTree>
       <p:nvGrpSpPr>
         <p:cNvPr id="1" name=""/>
@@ -5669,67 +4294,14 @@
       <p:grpSpPr/>
       <p:sp>
         <p:nvSpPr>
-          <p:cNvPr id="2" name="Rectangle 1"/>
-          <p:cNvSpPr/>
+          <p:cNvPr id="2" name="TextBox 1"/>
+          <p:cNvSpPr txBox="1"/>
           <p:nvPr/>
         </p:nvSpPr>
         <p:spPr>
           <a:xfrm>
-            <a:off x="0" y="0"/>
-            <a:ext cx="12188952" cy="777240"/>
-          </a:xfrm>
-          <a:prstGeom prst="rect">
-            <a:avLst/>
-          </a:prstGeom>
-          <a:solidFill>
-            <a:srgbClr val="0B3698"/>
-          </a:solidFill>
-          <a:ln>
-            <a:noFill/>
-          </a:ln>
-        </p:spPr>
-        <p:style>
-          <a:lnRef idx="1">
-            <a:schemeClr val="accent1"/>
-          </a:lnRef>
-          <a:fillRef idx="3">
-            <a:schemeClr val="accent1"/>
-          </a:fillRef>
-          <a:effectRef idx="2">
-            <a:schemeClr val="accent1"/>
-          </a:effectRef>
-          <a:fontRef idx="minor">
-            <a:schemeClr val="lt1"/>
-          </a:fontRef>
-        </p:style>
-        <p:txBody>
-          <a:bodyPr rtlCol="0" anchor="ctr" lIns="457200" tIns="109728"/>
-          <a:lstStyle/>
-          <a:p>
-            <a:pPr algn="l">
-              <a:defRPr sz="2600">
-                <a:solidFill>
-                  <a:srgbClr val="FFFFFF"/>
-                </a:solidFill>
-                <a:latin typeface="Calibri"/>
-              </a:defRPr>
-            </a:pPr>
-            <a:r>
-              <a:t>Flink Use Cases — Real-Time Intelligence</a:t>
-            </a:r>
-          </a:p>
-        </p:txBody>
-      </p:sp>
-      <p:sp>
-        <p:nvSpPr>
-          <p:cNvPr id="3" name="TextBox 2"/>
-          <p:cNvSpPr txBox="1"/>
-          <p:nvPr/>
-        </p:nvSpPr>
-        <p:spPr>
-          <a:xfrm>
-            <a:off x="457200" y="347472"/>
-            <a:ext cx="9144000" cy="274320"/>
+            <a:off x="457200" y="365760"/>
+            <a:ext cx="8229600" cy="640080"/>
           </a:xfrm>
           <a:prstGeom prst="rect">
             <a:avLst/>
@@ -5742,73 +4314,25 @@
           </a:bodyPr>
           <a:lstStyle/>
           <a:p>
-            <a:pPr algn="l">
-              <a:defRPr sz="1300">
-                <a:solidFill>
-                  <a:srgbClr val="D9E7FC"/>
-                </a:solidFill>
-                <a:latin typeface="Calibri"/>
-              </a:defRPr>
-            </a:pPr>
-            <a:r>
-              <a:t>Stateful stream computing on Confluent</a:t>
-            </a:r>
-          </a:p>
-        </p:txBody>
-      </p:sp>
-      <p:sp>
-        <p:nvSpPr>
-          <p:cNvPr id="4" name="Rectangle 3"/>
-          <p:cNvSpPr/>
+            <a:pPr>
+              <a:defRPr sz="2800" b="1"/>
+            </a:pPr>
+            <a:r>
+              <a:t>Stream Computing: Flink at a Glance</a:t>
+            </a:r>
+          </a:p>
+        </p:txBody>
+      </p:sp>
+      <p:sp>
+        <p:nvSpPr>
+          <p:cNvPr id="3" name="TextBox 2"/>
+          <p:cNvSpPr txBox="1"/>
           <p:nvPr/>
         </p:nvSpPr>
         <p:spPr>
           <a:xfrm>
-            <a:off x="228600" y="1005840"/>
-            <a:ext cx="11731752" cy="5577840"/>
-          </a:xfrm>
-          <a:prstGeom prst="rect">
-            <a:avLst/>
-          </a:prstGeom>
-          <a:noFill/>
-          <a:ln w="12700">
-            <a:solidFill>
-              <a:srgbClr val="C0D0F0"/>
-            </a:solidFill>
-          </a:ln>
-        </p:spPr>
-        <p:style>
-          <a:lnRef idx="1">
-            <a:schemeClr val="accent1"/>
-          </a:lnRef>
-          <a:fillRef idx="3">
-            <a:schemeClr val="accent1"/>
-          </a:fillRef>
-          <a:effectRef idx="2">
-            <a:schemeClr val="accent1"/>
-          </a:effectRef>
-          <a:fontRef idx="minor">
-            <a:schemeClr val="lt1"/>
-          </a:fontRef>
-        </p:style>
-        <p:txBody>
-          <a:bodyPr rtlCol="0" anchor="ctr"/>
-          <a:lstStyle/>
-          <a:p>
-            <a:pPr algn="ctr"/>
-          </a:p>
-        </p:txBody>
-      </p:sp>
-      <p:sp>
-        <p:nvSpPr>
-          <p:cNvPr id="5" name="TextBox 4"/>
-          <p:cNvSpPr txBox="1"/>
-          <p:nvPr/>
-        </p:nvSpPr>
-        <p:spPr>
-          <a:xfrm>
-            <a:off x="548640" y="1097280"/>
-            <a:ext cx="10972800" cy="5029200"/>
+            <a:off x="457200" y="1188720"/>
+            <a:ext cx="8229600" cy="5486400"/>
           </a:xfrm>
           <a:prstGeom prst="rect">
             <a:avLst/>
@@ -5822,86 +4346,50 @@
           <a:lstStyle/>
           <a:p>
             <a:pPr>
-              <a:spcBef>
-                <a:spcPts val="200"/>
-              </a:spcBef>
-              <a:spcAft>
-                <a:spcPts val="300"/>
-              </a:spcAft>
-            </a:pPr>
-            <a:r>
-              <a:rPr sz="1600">
-                <a:solidFill>
-                  <a:srgbClr val="1A1A1A"/>
-                </a:solidFill>
-                <a:latin typeface="Calibri"/>
-              </a:rPr>
-              <a:t>• Reporting (regulatory + operational, payments + ledger):
-  - Continuous aggregation of transaction and ledger events.
-  - Produces reporting-ready streams into Delta Lake for audits and exec reports.</a:t>
-            </a:r>
-          </a:p>
-          <a:p>
-            <a:pPr>
-              <a:spcBef>
-                <a:spcPts val="200"/>
-              </a:spcBef>
-              <a:spcAft>
-                <a:spcPts val="300"/>
-              </a:spcAft>
-            </a:pPr>
-            <a:r>
-              <a:rPr sz="1600">
-                <a:solidFill>
-                  <a:srgbClr val="1A1A1A"/>
-                </a:solidFill>
-                <a:latin typeface="Calibri"/>
-              </a:rPr>
-              <a:t>• Statements (payments + ledger):
-  - Real-time, per-customer, per-account assembly of statements from payment and ledger events.
-  - Ensures consistent ordering and idempotency.</a:t>
-            </a:r>
-          </a:p>
-          <a:p>
-            <a:pPr>
-              <a:spcBef>
-                <a:spcPts val="200"/>
-              </a:spcBef>
-              <a:spcAft>
-                <a:spcPts val="300"/>
-              </a:spcAft>
-            </a:pPr>
-            <a:r>
-              <a:rPr sz="1600">
-                <a:solidFill>
-                  <a:srgbClr val="1A1A1A"/>
-                </a:solidFill>
-                <a:latin typeface="Calibri"/>
-              </a:rPr>
-              <a:t>• Cash flow forecasting (Treasury / TBP):
-  - Near-real-time projected cash flows (T+0/T+1/T+7/T+30) from payments, trades, vendor flows.
-  - Triggers alerts when forecasts breach thresholds.</a:t>
-            </a:r>
-          </a:p>
-          <a:p>
-            <a:pPr>
-              <a:spcBef>
-                <a:spcPts val="200"/>
-              </a:spcBef>
-              <a:spcAft>
-                <a:spcPts val="300"/>
-              </a:spcAft>
-            </a:pPr>
-            <a:r>
-              <a:rPr sz="1600">
-                <a:solidFill>
-                  <a:srgbClr val="1A1A1A"/>
-                </a:solidFill>
-                <a:latin typeface="Calibri"/>
-              </a:rPr>
-              <a:t>• Liquidity monitoring (real-time):
-  - Continuous liquidity position tracking per entity/pool/currency.
-  - Detects breaches and concentration anomalies; can trigger compensating actions.</a:t>
+              <a:defRPr sz="1800"/>
+            </a:pPr>
+            <a:r>
+              <a:t>Flink runs on Kubernetes; connected to Confluent and Databricks.</a:t>
+            </a:r>
+          </a:p>
+          <a:p>
+            <a:pPr>
+              <a:defRPr sz="1800"/>
+            </a:pPr>
+            <a:r>
+              <a:t>Purpose: stateful, real-time computation across:</a:t>
+            </a:r>
+          </a:p>
+          <a:p>
+            <a:pPr>
+              <a:defRPr sz="1800"/>
+            </a:pPr>
+            <a:r>
+              <a:t>- Payments and ledger events</a:t>
+            </a:r>
+          </a:p>
+          <a:p>
+            <a:pPr>
+              <a:defRPr sz="1800"/>
+            </a:pPr>
+            <a:r>
+              <a:t>- Vendor-hosted events (TF/SCF)</a:t>
+            </a:r>
+          </a:p>
+          <a:p>
+            <a:pPr>
+              <a:defRPr sz="1800"/>
+            </a:pPr>
+            <a:r>
+              <a:t>- Kinetic actions and mandates</a:t>
+            </a:r>
+          </a:p>
+          <a:p>
+            <a:pPr>
+              <a:defRPr sz="1800"/>
+            </a:pPr>
+            <a:r>
+              <a:t>Not 'dumb pipes'; Flink joins streams with graph/reference data and enforces rules in motion.</a:t>
             </a:r>
           </a:p>
         </p:txBody>
@@ -5917,14 +4405,6 @@
 <file path=ppt/slides/slide9.xml><?xml version="1.0" encoding="utf-8"?>
 <p:sld xmlns:a="http://schemas.openxmlformats.org/drawingml/2006/main" xmlns:p="http://schemas.openxmlformats.org/presentationml/2006/main" xmlns:r="http://schemas.openxmlformats.org/officeDocument/2006/relationships">
   <p:cSld>
-    <p:bg>
-      <p:bgPr>
-        <a:solidFill>
-          <a:srgbClr val="FFFFFF"/>
-        </a:solidFill>
-        <a:effectLst/>
-      </p:bgPr>
-    </p:bg>
     <p:spTree>
       <p:nvGrpSpPr>
         <p:cNvPr id="1" name=""/>
@@ -5934,67 +4414,14 @@
       <p:grpSpPr/>
       <p:sp>
         <p:nvSpPr>
-          <p:cNvPr id="2" name="Rectangle 1"/>
-          <p:cNvSpPr/>
+          <p:cNvPr id="2" name="TextBox 1"/>
+          <p:cNvSpPr txBox="1"/>
           <p:nvPr/>
         </p:nvSpPr>
         <p:spPr>
           <a:xfrm>
-            <a:off x="0" y="0"/>
-            <a:ext cx="12188952" cy="777240"/>
-          </a:xfrm>
-          <a:prstGeom prst="rect">
-            <a:avLst/>
-          </a:prstGeom>
-          <a:solidFill>
-            <a:srgbClr val="0B3698"/>
-          </a:solidFill>
-          <a:ln>
-            <a:noFill/>
-          </a:ln>
-        </p:spPr>
-        <p:style>
-          <a:lnRef idx="1">
-            <a:schemeClr val="accent1"/>
-          </a:lnRef>
-          <a:fillRef idx="3">
-            <a:schemeClr val="accent1"/>
-          </a:fillRef>
-          <a:effectRef idx="2">
-            <a:schemeClr val="accent1"/>
-          </a:effectRef>
-          <a:fontRef idx="minor">
-            <a:schemeClr val="lt1"/>
-          </a:fontRef>
-        </p:style>
-        <p:txBody>
-          <a:bodyPr rtlCol="0" anchor="ctr" lIns="457200" tIns="109728"/>
-          <a:lstStyle/>
-          <a:p>
-            <a:pPr algn="l">
-              <a:defRPr sz="2600">
-                <a:solidFill>
-                  <a:srgbClr val="FFFFFF"/>
-                </a:solidFill>
-                <a:latin typeface="Calibri"/>
-              </a:defRPr>
-            </a:pPr>
-            <a:r>
-              <a:t>How It All Fits Together</a:t>
-            </a:r>
-          </a:p>
-        </p:txBody>
-      </p:sp>
-      <p:sp>
-        <p:nvSpPr>
-          <p:cNvPr id="3" name="TextBox 2"/>
-          <p:cNvSpPr txBox="1"/>
-          <p:nvPr/>
-        </p:nvSpPr>
-        <p:spPr>
-          <a:xfrm>
-            <a:off x="457200" y="347472"/>
-            <a:ext cx="9144000" cy="274320"/>
+            <a:off x="457200" y="365760"/>
+            <a:ext cx="8229600" cy="640080"/>
           </a:xfrm>
           <a:prstGeom prst="rect">
             <a:avLst/>
@@ -6007,97 +4434,25 @@
           </a:bodyPr>
           <a:lstStyle/>
           <a:p>
-            <a:pPr algn="l">
-              <a:defRPr sz="1300">
-                <a:solidFill>
-                  <a:srgbClr val="D9E7FC"/>
-                </a:solidFill>
-                <a:latin typeface="Calibri"/>
-              </a:defRPr>
-            </a:pPr>
-            <a:r>
-              <a:t>End-to-end blueprint at a glance</a:t>
-            </a:r>
-          </a:p>
-        </p:txBody>
-      </p:sp>
-      <p:sp>
-        <p:nvSpPr>
-          <p:cNvPr id="4" name="Rectangle 3"/>
-          <p:cNvSpPr/>
+            <a:pPr>
+              <a:defRPr sz="2800" b="1"/>
+            </a:pPr>
+            <a:r>
+              <a:t>Flink Use Case: Reporting (Regulatory + Operational)</a:t>
+            </a:r>
+          </a:p>
+        </p:txBody>
+      </p:sp>
+      <p:sp>
+        <p:nvSpPr>
+          <p:cNvPr id="3" name="TextBox 2"/>
+          <p:cNvSpPr txBox="1"/>
           <p:nvPr/>
         </p:nvSpPr>
         <p:spPr>
           <a:xfrm>
-            <a:off x="228600" y="1005840"/>
-            <a:ext cx="11731752" cy="5577840"/>
-          </a:xfrm>
-          <a:prstGeom prst="rect">
-            <a:avLst/>
-          </a:prstGeom>
-          <a:noFill/>
-          <a:ln w="12700">
-            <a:solidFill>
-              <a:srgbClr val="C0D0F0"/>
-            </a:solidFill>
-          </a:ln>
-        </p:spPr>
-        <p:style>
-          <a:lnRef idx="1">
-            <a:schemeClr val="accent1"/>
-          </a:lnRef>
-          <a:fillRef idx="3">
-            <a:schemeClr val="accent1"/>
-          </a:fillRef>
-          <a:effectRef idx="2">
-            <a:schemeClr val="accent1"/>
-          </a:effectRef>
-          <a:fontRef idx="minor">
-            <a:schemeClr val="lt1"/>
-          </a:fontRef>
-        </p:style>
-        <p:txBody>
-          <a:bodyPr rtlCol="0" anchor="ctr"/>
-          <a:lstStyle/>
-          <a:p>
-            <a:pPr algn="ctr"/>
-          </a:p>
-        </p:txBody>
-      </p:sp>
-      <p:pic>
-        <p:nvPicPr>
-          <p:cNvPr id="5" name="Picture 4" descr="end-to-end-blueprint.png"/>
-          <p:cNvPicPr>
-            <a:picLocks noChangeAspect="1"/>
-          </p:cNvPicPr>
-          <p:nvPr/>
-        </p:nvPicPr>
-        <p:blipFill>
-          <a:blip r:embed="rId2"/>
-          <a:stretch>
-            <a:fillRect/>
-          </a:stretch>
-        </p:blipFill>
-        <p:spPr>
-          <a:xfrm>
-            <a:off x="228600" y="1051560"/>
-            <a:ext cx="11731752" cy="3291840"/>
-          </a:xfrm>
-          <a:prstGeom prst="rect">
-            <a:avLst/>
-          </a:prstGeom>
-        </p:spPr>
-      </p:pic>
-      <p:sp>
-        <p:nvSpPr>
-          <p:cNvPr id="6" name="TextBox 5"/>
-          <p:cNvSpPr txBox="1"/>
-          <p:nvPr/>
-        </p:nvSpPr>
-        <p:spPr>
-          <a:xfrm>
-            <a:off x="548640" y="4572000"/>
-            <a:ext cx="10515600" cy="1828800"/>
+            <a:off x="457200" y="1188720"/>
+            <a:ext cx="8229600" cy="5486400"/>
           </a:xfrm>
           <a:prstGeom prst="rect">
             <a:avLst/>
@@ -6111,78 +4466,34 @@
           <a:lstStyle/>
           <a:p>
             <a:pPr>
-              <a:spcBef>
-                <a:spcPts val="200"/>
-              </a:spcBef>
-              <a:spcAft>
-                <a:spcPts val="300"/>
-              </a:spcAft>
-            </a:pPr>
-            <a:r>
-              <a:rPr sz="1700">
-                <a:solidFill>
-                  <a:srgbClr val="1A1A1A"/>
-                </a:solidFill>
-                <a:latin typeface="Calibri"/>
-              </a:rPr>
-              <a:t>• One ontology, one platform — shared canonical graph across all LOBs.</a:t>
-            </a:r>
-          </a:p>
-          <a:p>
-            <a:pPr>
-              <a:spcBef>
-                <a:spcPts val="200"/>
-              </a:spcBef>
-              <a:spcAft>
-                <a:spcPts val="300"/>
-              </a:spcAft>
-            </a:pPr>
-            <a:r>
-              <a:rPr sz="1700">
-                <a:solidFill>
-                  <a:srgbClr val="1A1A1A"/>
-                </a:solidFill>
-                <a:latin typeface="Calibri"/>
-              </a:rPr>
-              <a:t>• Actions, not CRUD — declared operations with proof, rules, and governance.</a:t>
-            </a:r>
-          </a:p>
-          <a:p>
-            <a:pPr>
-              <a:spcBef>
-                <a:spcPts val="200"/>
-              </a:spcBef>
-              <a:spcAft>
-                <a:spcPts val="300"/>
-              </a:spcAft>
-            </a:pPr>
-            <a:r>
-              <a:rPr sz="1700">
-                <a:solidFill>
-                  <a:srgbClr val="1A1A1A"/>
-                </a:solidFill>
-                <a:latin typeface="Calibri"/>
-              </a:rPr>
-              <a:t>• Streaming + Flink as the nervous system — real-time correlation and decisions.</a:t>
-            </a:r>
-          </a:p>
-          <a:p>
-            <a:pPr>
-              <a:spcBef>
-                <a:spcPts val="200"/>
-              </a:spcBef>
-              <a:spcAft>
-                <a:spcPts val="300"/>
-              </a:spcAft>
-            </a:pPr>
-            <a:r>
-              <a:rPr sz="1700">
-                <a:solidFill>
-                  <a:srgbClr val="1A1A1A"/>
-                </a:solidFill>
-                <a:latin typeface="Calibri"/>
-              </a:rPr>
-              <a:t>• Governance and trust baked in — mandates, audit, and reconstructibility by design.</a:t>
+              <a:defRPr sz="1800"/>
+            </a:pPr>
+            <a:r>
+              <a:t>Real-time aggregation of payments, ledger, and trade events using Flink.</a:t>
+            </a:r>
+          </a:p>
+          <a:p>
+            <a:pPr>
+              <a:defRPr sz="1800"/>
+            </a:pPr>
+            <a:r>
+              <a:t>Enriched with canonical entity/relationship context.</a:t>
+            </a:r>
+          </a:p>
+          <a:p>
+            <a:pPr>
+              <a:defRPr sz="1800"/>
+            </a:pPr>
+            <a:r>
+              <a:t>Produces reporting-ready streams into Delta Lake (tb_canonical.reporting).</a:t>
+            </a:r>
+          </a:p>
+          <a:p>
+            <a:pPr>
+              <a:defRPr sz="1800"/>
+            </a:pPr>
+            <a:r>
+              <a:t>Enables BCBS-239-aligned reporting, audits, and regulatory submissions.</a:t>
             </a:r>
           </a:p>
         </p:txBody>

</xml_diff>